<commit_message>
Expand the pilot dataset from 12 to 25 pairs, rerun Phase 1 embeddings with a control baseline and z-scores, and update the notebook and presentation with the finding that the "Paradoxo is worst" hierarchy didn't survive the larger sample.
Co-Authored-By: Claude Sonnet 5 <noreply@anthropic.com>
Claude-Session: https://claude.ai/code/session_01CVwu1A1WBBqmHkFYqFqo3h
</commit_message>
<xml_diff>
--- a/apresentacao/laboratorio_estresse_semantico.pptx
+++ b/apresentacao/laboratorio_estresse_semantico.pptx
@@ -6,11 +6,16 @@
   </p:sldMasterIdLst>
   <p:sldIdLst>
     <p:sldId id="256" r:id="rId7"/>
+    <p:sldId id="263" r:id="rId14"/>
     <p:sldId id="257" r:id="rId8"/>
     <p:sldId id="258" r:id="rId9"/>
     <p:sldId id="259" r:id="rId10"/>
+    <p:sldId id="264" r:id="rId15"/>
+    <p:sldId id="265" r:id="rId16"/>
     <p:sldId id="260" r:id="rId11"/>
     <p:sldId id="261" r:id="rId12"/>
+    <p:sldId id="266" r:id="rId17"/>
+    <p:sldId id="267" r:id="rId18"/>
     <p:sldId id="262" r:id="rId13"/>
   </p:sldIdLst>
   <p:sldSz cx="12191695" cy="6858000" type="screen4x3"/>
@@ -3303,6 +3308,2432 @@
 </p:sld>
 </file>
 
+<file path=ppt/slides/slide10.xml><?xml version="1.0" encoding="utf-8"?>
+<p:sld xmlns:a="http://schemas.openxmlformats.org/drawingml/2006/main" xmlns:p="http://schemas.openxmlformats.org/presentationml/2006/main" xmlns:r="http://schemas.openxmlformats.org/officeDocument/2006/relationships">
+  <p:cSld>
+    <p:bg>
+      <p:bgPr>
+        <a:solidFill>
+          <a:srgbClr val="FFFFFF"/>
+        </a:solidFill>
+        <a:effectLst/>
+      </p:bgPr>
+    </p:bg>
+    <p:spTree>
+      <p:nvGrpSpPr>
+        <p:cNvPr id="1" name=""/>
+        <p:cNvGrpSpPr/>
+        <p:nvPr/>
+      </p:nvGrpSpPr>
+      <p:grpSpPr/>
+      <p:sp>
+        <p:nvSpPr>
+          <p:cNvPr id="2" name="TextBox 2"/>
+          <p:cNvSpPr txBox="1"/>
+          <p:nvPr/>
+        </p:nvSpPr>
+        <p:spPr>
+          <a:xfrm>
+            <a:off x="640080" y="411480"/>
+            <a:ext cx="10911535" cy="320040"/>
+          </a:xfrm>
+          <a:prstGeom prst="rect">
+            <a:avLst/>
+          </a:prstGeom>
+          <a:noFill/>
+        </p:spPr>
+        <p:txBody>
+          <a:bodyPr wrap="square" lIns="0" rIns="0" tIns="0" bIns="0">
+            <a:spAutoFit/>
+          </a:bodyPr>
+          <a:lstStyle/>
+          <a:p>
+            <a:pPr algn="l"/>
+            <a:r>
+              <a:rPr sz="1200" b="1" i="0">
+                <a:solidFill>
+                  <a:srgbClr val="3B5BDB"/>
+                </a:solidFill>
+                <a:latin typeface="Calibri"/>
+              </a:rPr>
+              <a:t>EXEMPLO</a:t>
+            </a:r>
+          </a:p>
+        </p:txBody>
+      </p:sp>
+      <p:sp>
+        <p:nvSpPr>
+          <p:cNvPr id="3" name="TextBox 3"/>
+          <p:cNvSpPr txBox="1"/>
+          <p:nvPr/>
+        </p:nvSpPr>
+        <p:spPr>
+          <a:xfrm>
+            <a:off x="640080" y="777240"/>
+            <a:ext cx="10911535" cy="731520"/>
+          </a:xfrm>
+          <a:prstGeom prst="rect">
+            <a:avLst/>
+          </a:prstGeom>
+          <a:noFill/>
+        </p:spPr>
+        <p:txBody>
+          <a:bodyPr wrap="square" lIns="0" rIns="0" tIns="0" bIns="0">
+            <a:spAutoFit/>
+          </a:bodyPr>
+          <a:lstStyle/>
+          <a:p>
+            <a:pPr algn="l"/>
+            <a:r>
+              <a:rPr sz="3000" b="1" i="0">
+                <a:solidFill>
+                  <a:srgbClr val="1B2A4A"/>
+                </a:solidFill>
+                <a:latin typeface="Calibri"/>
+              </a:rPr>
+              <a:t>Um par do dataset: antítese em Vieira</a:t>
+            </a:r>
+          </a:p>
+        </p:txBody>
+      </p:sp>
+      <p:sp>
+        <p:nvSpPr>
+          <p:cNvPr id="4" name="Rounded Rectangle 4"/>
+          <p:cNvSpPr/>
+          <p:nvPr/>
+        </p:nvSpPr>
+        <p:spPr>
+          <a:xfrm>
+            <a:off x="640080" y="1600200"/>
+            <a:ext cx="5029200" cy="1350000"/>
+          </a:xfrm>
+          <a:prstGeom prst="roundRect">
+            <a:avLst>
+              <a:gd name="adj" fmla="val 6000"/>
+            </a:avLst>
+          </a:prstGeom>
+          <a:solidFill>
+            <a:srgbClr val="FDECE0"/>
+          </a:solidFill>
+          <a:ln>
+            <a:noFill/>
+          </a:ln>
+          <a:effectLst/>
+        </p:spPr>
+        <p:style>
+          <a:lnRef idx="1">
+            <a:schemeClr val="accent1"/>
+          </a:lnRef>
+          <a:fillRef idx="3">
+            <a:schemeClr val="accent1"/>
+          </a:fillRef>
+          <a:effectRef idx="2">
+            <a:schemeClr val="accent1"/>
+          </a:effectRef>
+          <a:fontRef idx="minor">
+            <a:schemeClr val="lt1"/>
+          </a:fontRef>
+        </p:style>
+        <p:txBody>
+          <a:bodyPr rtlCol="0" anchor="ctr" wrap="square" lIns="274320" rIns="274320"/>
+          <a:lstStyle/>
+          <a:p>
+            <a:pPr algn="l">
+              <a:lnSpc>
+                <a:spcPct val="120000"/>
+              </a:lnSpc>
+            </a:pPr>
+            <a:r>
+              <a:rPr sz="1150" b="1" i="0">
+                <a:solidFill>
+                  <a:srgbClr val="E8590C"/>
+                </a:solidFill>
+                <a:latin typeface="Calibri"/>
+              </a:rPr>
+              <a:t>TEXTO ORIGINAL (COMPLEXO)</a:t>
+            </a:r>
+          </a:p>
+          <a:p>
+            <a:pPr algn="l">
+              <a:lnSpc>
+                <a:spcPct val="120000"/>
+              </a:lnSpc>
+              <a:spcBef>
+                <a:spcPts val="500"/>
+              </a:spcBef>
+            </a:pPr>
+            <a:r>
+              <a:rPr sz="1400" b="0" i="1">
+                <a:solidFill>
+                  <a:srgbClr val="1B2A4A"/>
+                </a:solidFill>
+                <a:latin typeface="Calibri"/>
+              </a:rPr>
+              <a:t>“Mas ainda a [desgraça] do semeador do nosso Evangelho não foi a maior. A maior é a que se tem experimentado na seara aonde eu fui, e para onde venho.”</a:t>
+            </a:r>
+          </a:p>
+        </p:txBody>
+      </p:sp>
+      <p:sp>
+        <p:nvSpPr>
+          <p:cNvPr id="5" name="Rounded Rectangle 5"/>
+          <p:cNvSpPr/>
+          <p:nvPr/>
+        </p:nvSpPr>
+        <p:spPr>
+          <a:xfrm>
+            <a:off x="6263640" y="1600200"/>
+            <a:ext cx="5212080" cy="1350000"/>
+          </a:xfrm>
+          <a:prstGeom prst="roundRect">
+            <a:avLst>
+              <a:gd name="adj" fmla="val 6000"/>
+            </a:avLst>
+          </a:prstGeom>
+          <a:solidFill>
+            <a:srgbClr val="DFF6EE"/>
+          </a:solidFill>
+          <a:ln>
+            <a:noFill/>
+          </a:ln>
+          <a:effectLst/>
+        </p:spPr>
+        <p:style>
+          <a:lnRef idx="1">
+            <a:schemeClr val="accent1"/>
+          </a:lnRef>
+          <a:fillRef idx="3">
+            <a:schemeClr val="accent1"/>
+          </a:fillRef>
+          <a:effectRef idx="2">
+            <a:schemeClr val="accent1"/>
+          </a:effectRef>
+          <a:fontRef idx="minor">
+            <a:schemeClr val="lt1"/>
+          </a:fontRef>
+        </p:style>
+        <p:txBody>
+          <a:bodyPr rtlCol="0" anchor="ctr" wrap="square" lIns="274320" rIns="274320"/>
+          <a:lstStyle/>
+          <a:p>
+            <a:pPr algn="l">
+              <a:lnSpc>
+                <a:spcPct val="120000"/>
+              </a:lnSpc>
+            </a:pPr>
+            <a:r>
+              <a:rPr sz="1150" b="1" i="0">
+                <a:solidFill>
+                  <a:srgbClr val="0CA678"/>
+                </a:solidFill>
+                <a:latin typeface="Calibri"/>
+              </a:rPr>
+              <a:t>TEXTO SIMPLIFICADO</a:t>
+            </a:r>
+          </a:p>
+          <a:p>
+            <a:pPr algn="l">
+              <a:lnSpc>
+                <a:spcPct val="120000"/>
+              </a:lnSpc>
+              <a:spcBef>
+                <a:spcPts val="500"/>
+              </a:spcBef>
+            </a:pPr>
+            <a:r>
+              <a:rPr sz="1400" b="0" i="1">
+                <a:solidFill>
+                  <a:srgbClr val="1B2A4A"/>
+                </a:solidFill>
+                <a:latin typeface="Calibri"/>
+              </a:rPr>
+              <a:t>“No entanto, o sofrimento dos pregadores do Evangelho em geral não foi o pior. O pior sofrimento é aquele que os missionários vivenciaram na região do Maranhão, de onde eu voltei recentemente e para onde pretendo ir novamente.”</a:t>
+            </a:r>
+          </a:p>
+        </p:txBody>
+      </p:sp>
+      <p:sp>
+        <p:nvSpPr>
+          <p:cNvPr id="6" name="TextBox 6"/>
+          <p:cNvSpPr txBox="1"/>
+          <p:nvPr/>
+        </p:nvSpPr>
+        <p:spPr>
+          <a:xfrm>
+            <a:off x="640080" y="3178800"/>
+            <a:ext cx="10911535" cy="750000"/>
+          </a:xfrm>
+          <a:prstGeom prst="rect">
+            <a:avLst/>
+          </a:prstGeom>
+          <a:noFill/>
+        </p:spPr>
+        <p:txBody>
+          <a:bodyPr wrap="square" lIns="0" rIns="0" tIns="0" bIns="0">
+            <a:spAutoFit/>
+          </a:bodyPr>
+          <a:lstStyle/>
+          <a:p>
+            <a:pPr algn="l">
+              <a:lnSpc>
+                <a:spcPct val="120000"/>
+              </a:lnSpc>
+            </a:pPr>
+            <a:r>
+              <a:rPr sz="1500" b="0" i="0">
+                <a:solidFill>
+                  <a:srgbClr val="495057"/>
+                </a:solidFill>
+                <a:latin typeface="Calibri"/>
+              </a:rPr>
+              <a:t>Ambos dizem essencialmente a mesma coisa, mas o original usa a antítese retórica de Vieira (“não foi a maior… a maior é…”), enquanto a versão simplificada reescreve isso de forma direta. Esse é um dos pares com maior divergência entre os três modelos testados na análise exploratória.</a:t>
+            </a:r>
+          </a:p>
+        </p:txBody>
+      </p:sp>
+      <p:sp>
+        <p:nvSpPr>
+          <p:cNvPr id="7" name="Rounded Rectangle 7"/>
+          <p:cNvSpPr/>
+          <p:nvPr/>
+        </p:nvSpPr>
+        <p:spPr>
+          <a:xfrm>
+            <a:off x="640080" y="4157400"/>
+            <a:ext cx="3484778" cy="685800"/>
+          </a:xfrm>
+          <a:prstGeom prst="roundRect">
+            <a:avLst>
+              <a:gd name="adj" fmla="val 14000"/>
+            </a:avLst>
+          </a:prstGeom>
+          <a:solidFill>
+            <a:srgbClr val="F6F7F9"/>
+          </a:solidFill>
+          <a:ln>
+            <a:noFill/>
+          </a:ln>
+          <a:effectLst/>
+        </p:spPr>
+        <p:style>
+          <a:lnRef idx="1">
+            <a:schemeClr val="accent1"/>
+          </a:lnRef>
+          <a:fillRef idx="3">
+            <a:schemeClr val="accent1"/>
+          </a:fillRef>
+          <a:effectRef idx="2">
+            <a:schemeClr val="accent1"/>
+          </a:effectRef>
+          <a:fontRef idx="minor">
+            <a:schemeClr val="lt1"/>
+          </a:fontRef>
+        </p:style>
+        <p:txBody>
+          <a:bodyPr rtlCol="0" anchor="ctr" wrap="square" lIns="228600" rIns="228600"/>
+          <a:lstStyle/>
+          <a:p>
+            <a:pPr algn="ctr"/>
+            <a:r>
+              <a:rPr sz="1450" b="1" i="0">
+                <a:solidFill>
+                  <a:srgbClr val="1B2A4A"/>
+                </a:solidFill>
+                <a:latin typeface="Calibri"/>
+              </a:rPr>
+              <a:t>BGE-M3  </a:t>
+            </a:r>
+            <a:r>
+              <a:rPr sz="1450" b="0" i="0">
+                <a:solidFill>
+                  <a:srgbClr val="868E96"/>
+                </a:solidFill>
+                <a:latin typeface="Calibri"/>
+              </a:rPr>
+              <a:t>≈ 0,71</a:t>
+            </a:r>
+          </a:p>
+        </p:txBody>
+      </p:sp>
+      <p:sp>
+        <p:nvSpPr>
+          <p:cNvPr id="8" name="Rounded Rectangle 8"/>
+          <p:cNvSpPr/>
+          <p:nvPr/>
+        </p:nvSpPr>
+        <p:spPr>
+          <a:xfrm>
+            <a:off x="4353458" y="4157400"/>
+            <a:ext cx="3484778" cy="685800"/>
+          </a:xfrm>
+          <a:prstGeom prst="roundRect">
+            <a:avLst>
+              <a:gd name="adj" fmla="val 14000"/>
+            </a:avLst>
+          </a:prstGeom>
+          <a:solidFill>
+            <a:srgbClr val="F6F7F9"/>
+          </a:solidFill>
+          <a:ln>
+            <a:noFill/>
+          </a:ln>
+          <a:effectLst/>
+        </p:spPr>
+        <p:style>
+          <a:lnRef idx="1">
+            <a:schemeClr val="accent1"/>
+          </a:lnRef>
+          <a:fillRef idx="3">
+            <a:schemeClr val="accent1"/>
+          </a:fillRef>
+          <a:effectRef idx="2">
+            <a:schemeClr val="accent1"/>
+          </a:effectRef>
+          <a:fontRef idx="minor">
+            <a:schemeClr val="lt1"/>
+          </a:fontRef>
+        </p:style>
+        <p:txBody>
+          <a:bodyPr rtlCol="0" anchor="ctr" wrap="square" lIns="228600" rIns="228600"/>
+          <a:lstStyle/>
+          <a:p>
+            <a:pPr algn="ctr"/>
+            <a:r>
+              <a:rPr sz="1450" b="1" i="0">
+                <a:solidFill>
+                  <a:srgbClr val="1B2A4A"/>
+                </a:solidFill>
+                <a:latin typeface="Calibri"/>
+              </a:rPr>
+              <a:t>LaBSE  </a:t>
+            </a:r>
+            <a:r>
+              <a:rPr sz="1450" b="0" i="0">
+                <a:solidFill>
+                  <a:srgbClr val="868E96"/>
+                </a:solidFill>
+                <a:latin typeface="Calibri"/>
+              </a:rPr>
+              <a:t>≈ 0,74</a:t>
+            </a:r>
+          </a:p>
+        </p:txBody>
+      </p:sp>
+      <p:sp>
+        <p:nvSpPr>
+          <p:cNvPr id="9" name="Rounded Rectangle 9"/>
+          <p:cNvSpPr/>
+          <p:nvPr/>
+        </p:nvSpPr>
+        <p:spPr>
+          <a:xfrm>
+            <a:off x="8066836" y="4157400"/>
+            <a:ext cx="3484778" cy="685800"/>
+          </a:xfrm>
+          <a:prstGeom prst="roundRect">
+            <a:avLst>
+              <a:gd name="adj" fmla="val 14000"/>
+            </a:avLst>
+          </a:prstGeom>
+          <a:solidFill>
+            <a:srgbClr val="F6F7F9"/>
+          </a:solidFill>
+          <a:ln>
+            <a:noFill/>
+          </a:ln>
+          <a:effectLst/>
+        </p:spPr>
+        <p:style>
+          <a:lnRef idx="1">
+            <a:schemeClr val="accent1"/>
+          </a:lnRef>
+          <a:fillRef idx="3">
+            <a:schemeClr val="accent1"/>
+          </a:fillRef>
+          <a:effectRef idx="2">
+            <a:schemeClr val="accent1"/>
+          </a:effectRef>
+          <a:fontRef idx="minor">
+            <a:schemeClr val="lt1"/>
+          </a:fontRef>
+        </p:style>
+        <p:txBody>
+          <a:bodyPr rtlCol="0" anchor="ctr" wrap="square" lIns="228600" rIns="228600"/>
+          <a:lstStyle/>
+          <a:p>
+            <a:pPr algn="ctr"/>
+            <a:r>
+              <a:rPr sz="1450" b="1" i="0">
+                <a:solidFill>
+                  <a:srgbClr val="1B2A4A"/>
+                </a:solidFill>
+                <a:latin typeface="Calibri"/>
+              </a:rPr>
+              <a:t>EmbeddingGemma  </a:t>
+            </a:r>
+            <a:r>
+              <a:rPr sz="1450" b="0" i="0">
+                <a:solidFill>
+                  <a:srgbClr val="868E96"/>
+                </a:solidFill>
+                <a:latin typeface="Calibri"/>
+              </a:rPr>
+              <a:t>≈ 0,60</a:t>
+            </a:r>
+          </a:p>
+        </p:txBody>
+      </p:sp>
+      <p:sp>
+        <p:nvSpPr>
+          <p:cNvPr id="10" name="Rounded Rectangle 10"/>
+          <p:cNvSpPr/>
+          <p:nvPr/>
+        </p:nvSpPr>
+        <p:spPr>
+          <a:xfrm>
+            <a:off x="640080" y="5532120"/>
+            <a:ext cx="10911535" cy="777240"/>
+          </a:xfrm>
+          <a:prstGeom prst="roundRect">
+            <a:avLst>
+              <a:gd name="adj" fmla="val 10000"/>
+            </a:avLst>
+          </a:prstGeom>
+          <a:solidFill>
+            <a:srgbClr val="E7ECFC"/>
+          </a:solidFill>
+          <a:ln>
+            <a:noFill/>
+          </a:ln>
+          <a:effectLst/>
+        </p:spPr>
+        <p:style>
+          <a:lnRef idx="1">
+            <a:schemeClr val="accent1"/>
+          </a:lnRef>
+          <a:fillRef idx="3">
+            <a:schemeClr val="accent1"/>
+          </a:fillRef>
+          <a:effectRef idx="2">
+            <a:schemeClr val="accent1"/>
+          </a:effectRef>
+          <a:fontRef idx="minor">
+            <a:schemeClr val="lt1"/>
+          </a:fontRef>
+        </p:style>
+        <p:txBody>
+          <a:bodyPr rtlCol="0" anchor="ctr" wrap="square" lIns="320040" rIns="320040"/>
+          <a:lstStyle/>
+          <a:p>
+            <a:pPr algn="l">
+              <a:lnSpc>
+                <a:spcPct val="112000"/>
+              </a:lnSpc>
+            </a:pPr>
+            <a:r>
+              <a:rPr sz="1400" b="0" i="1">
+                <a:solidFill>
+                  <a:srgbClr val="1B2A4A"/>
+                </a:solidFill>
+                <a:latin typeface="Calibri"/>
+              </a:rPr>
+              <a:t>Padrão consistente com o piloto: figuras que dependem de oposição lógica — como a antítese — tendem a “derivar” mais no espaço de embedding do que reconstruções puramente sintáticas.</a:t>
+            </a:r>
+          </a:p>
+        </p:txBody>
+      </p:sp>
+      <p:sp>
+        <p:nvSpPr>
+          <p:cNvPr id="11" name="TextBox 11"/>
+          <p:cNvSpPr txBox="1"/>
+          <p:nvPr/>
+        </p:nvSpPr>
+        <p:spPr>
+          <a:xfrm>
+            <a:off x="640080" y="6400800"/>
+            <a:ext cx="5486400" cy="320040"/>
+          </a:xfrm>
+          <a:prstGeom prst="rect">
+            <a:avLst/>
+          </a:prstGeom>
+          <a:noFill/>
+        </p:spPr>
+        <p:txBody>
+          <a:bodyPr wrap="square" lIns="0" rIns="0" tIns="0" bIns="0">
+            <a:spAutoFit/>
+          </a:bodyPr>
+          <a:lstStyle/>
+          <a:p>
+            <a:pPr algn="l"/>
+            <a:r>
+              <a:rPr sz="1000" b="0" i="0">
+                <a:solidFill>
+                  <a:srgbClr val="868E96"/>
+                </a:solidFill>
+                <a:latin typeface="Calibri"/>
+              </a:rPr>
+              <a:t>Laboratório de Estresse Semântico</a:t>
+            </a:r>
+          </a:p>
+        </p:txBody>
+      </p:sp>
+      <p:sp>
+        <p:nvSpPr>
+          <p:cNvPr id="12" name="TextBox 12"/>
+          <p:cNvSpPr txBox="1"/>
+          <p:nvPr/>
+        </p:nvSpPr>
+        <p:spPr>
+          <a:xfrm>
+            <a:off x="10637215" y="6400800"/>
+            <a:ext cx="914400" cy="320040"/>
+          </a:xfrm>
+          <a:prstGeom prst="rect">
+            <a:avLst/>
+          </a:prstGeom>
+          <a:noFill/>
+        </p:spPr>
+        <p:txBody>
+          <a:bodyPr wrap="square" lIns="0" rIns="0" tIns="0" bIns="0">
+            <a:spAutoFit/>
+          </a:bodyPr>
+          <a:lstStyle/>
+          <a:p>
+            <a:pPr algn="r"/>
+            <a:r>
+              <a:rPr sz="1000" b="0" i="0">
+                <a:solidFill>
+                  <a:srgbClr val="868E96"/>
+                </a:solidFill>
+                <a:latin typeface="Calibri"/>
+              </a:rPr>
+              <a:t>7</a:t>
+            </a:r>
+          </a:p>
+        </p:txBody>
+      </p:sp>
+    </p:spTree>
+  </p:cSld>
+  <p:clrMapOvr>
+    <a:masterClrMapping/>
+  </p:clrMapOvr>
+</p:sld>
+</file>
+
+<file path=ppt/slides/slide11.xml><?xml version="1.0" encoding="utf-8"?>
+<p:sld xmlns:a="http://schemas.openxmlformats.org/drawingml/2006/main" xmlns:p="http://schemas.openxmlformats.org/presentationml/2006/main" xmlns:r="http://schemas.openxmlformats.org/officeDocument/2006/relationships">
+  <p:cSld>
+    <p:bg>
+      <p:bgPr>
+        <a:solidFill>
+          <a:srgbClr val="FFFFFF"/>
+        </a:solidFill>
+        <a:effectLst/>
+      </p:bgPr>
+    </p:bg>
+    <p:spTree>
+      <p:nvGrpSpPr>
+        <p:cNvPr id="1" name=""/>
+        <p:cNvGrpSpPr/>
+        <p:nvPr/>
+      </p:nvGrpSpPr>
+      <p:grpSpPr/>
+      <p:sp>
+        <p:nvSpPr>
+          <p:cNvPr id="2" name="TextBox 2"/>
+          <p:cNvSpPr txBox="1"/>
+          <p:nvPr/>
+        </p:nvSpPr>
+        <p:spPr>
+          <a:xfrm>
+            <a:off x="640080" y="411480"/>
+            <a:ext cx="10911535" cy="320040"/>
+          </a:xfrm>
+          <a:prstGeom prst="rect">
+            <a:avLst/>
+          </a:prstGeom>
+          <a:noFill/>
+        </p:spPr>
+        <p:txBody>
+          <a:bodyPr wrap="square" lIns="0" rIns="0" tIns="0" bIns="0">
+            <a:spAutoFit/>
+          </a:bodyPr>
+          <a:lstStyle/>
+          <a:p>
+            <a:pPr algn="l"/>
+            <a:r>
+              <a:rPr sz="1200" b="1" i="0">
+                <a:solidFill>
+                  <a:srgbClr val="3B5BDB"/>
+                </a:solidFill>
+                <a:latin typeface="Calibri"/>
+              </a:rPr>
+              <a:t>CONTROLE METODOLÓGICO</a:t>
+            </a:r>
+          </a:p>
+        </p:txBody>
+      </p:sp>
+      <p:sp>
+        <p:nvSpPr>
+          <p:cNvPr id="3" name="TextBox 3"/>
+          <p:cNvSpPr txBox="1"/>
+          <p:nvPr/>
+        </p:nvSpPr>
+        <p:spPr>
+          <a:xfrm>
+            <a:off x="640080" y="777240"/>
+            <a:ext cx="10911535" cy="731520"/>
+          </a:xfrm>
+          <a:prstGeom prst="rect">
+            <a:avLst/>
+          </a:prstGeom>
+          <a:noFill/>
+        </p:spPr>
+        <p:txBody>
+          <a:bodyPr wrap="square" lIns="0" rIns="0" tIns="0" bIns="0">
+            <a:spAutoFit/>
+          </a:bodyPr>
+          <a:lstStyle/>
+          <a:p>
+            <a:pPr algn="l"/>
+            <a:r>
+              <a:rPr sz="3000" b="1" i="0">
+                <a:solidFill>
+                  <a:srgbClr val="1B2A4A"/>
+                </a:solidFill>
+                <a:latin typeface="Calibri"/>
+              </a:rPr>
+              <a:t>Fenômeno retórico ou contexto perdido?</a:t>
+            </a:r>
+          </a:p>
+        </p:txBody>
+      </p:sp>
+      <p:sp>
+        <p:nvSpPr>
+          <p:cNvPr id="4" name="Rounded Rectangle 4"/>
+          <p:cNvSpPr/>
+          <p:nvPr/>
+        </p:nvSpPr>
+        <p:spPr>
+          <a:xfrm>
+            <a:off x="640080" y="1600200"/>
+            <a:ext cx="5212080" cy="3246120"/>
+          </a:xfrm>
+          <a:prstGeom prst="roundRect">
+            <a:avLst>
+              <a:gd name="adj" fmla="val 6000"/>
+            </a:avLst>
+          </a:prstGeom>
+          <a:solidFill>
+            <a:srgbClr val="F6F7F9"/>
+          </a:solidFill>
+          <a:ln>
+            <a:noFill/>
+          </a:ln>
+          <a:effectLst/>
+        </p:spPr>
+        <p:style>
+          <a:lnRef idx="1">
+            <a:schemeClr val="accent1"/>
+          </a:lnRef>
+          <a:fillRef idx="3">
+            <a:schemeClr val="accent1"/>
+          </a:fillRef>
+          <a:effectRef idx="2">
+            <a:schemeClr val="accent1"/>
+          </a:effectRef>
+          <a:fontRef idx="minor">
+            <a:schemeClr val="lt1"/>
+          </a:fontRef>
+        </p:style>
+        <p:txBody>
+          <a:bodyPr rtlCol="0" anchor="ctr"/>
+          <a:lstStyle/>
+          <a:p>
+            <a:pPr algn="ctr"/>
+          </a:p>
+        </p:txBody>
+      </p:sp>
+      <p:sp>
+        <p:nvSpPr>
+          <p:cNvPr id="5" name="Rounded Rectangle 5"/>
+          <p:cNvSpPr/>
+          <p:nvPr/>
+        </p:nvSpPr>
+        <p:spPr>
+          <a:xfrm>
+            <a:off x="914400" y="1856232"/>
+            <a:ext cx="3450000" cy="365760"/>
+          </a:xfrm>
+          <a:prstGeom prst="roundRect">
+            <a:avLst>
+              <a:gd name="adj" fmla="val 50000"/>
+            </a:avLst>
+          </a:prstGeom>
+          <a:solidFill>
+            <a:srgbClr val="FDECE0"/>
+          </a:solidFill>
+          <a:ln>
+            <a:noFill/>
+          </a:ln>
+          <a:effectLst/>
+        </p:spPr>
+        <p:style>
+          <a:lnRef idx="1">
+            <a:schemeClr val="accent1"/>
+          </a:lnRef>
+          <a:fillRef idx="3">
+            <a:schemeClr val="accent1"/>
+          </a:fillRef>
+          <a:effectRef idx="2">
+            <a:schemeClr val="accent1"/>
+          </a:effectRef>
+          <a:fontRef idx="minor">
+            <a:schemeClr val="lt1"/>
+          </a:fontRef>
+        </p:style>
+        <p:txBody>
+          <a:bodyPr rtlCol="0" anchor="ctr" wrap="square" lIns="228600" rIns="228600"/>
+          <a:lstStyle/>
+          <a:p>
+            <a:pPr algn="ctr"/>
+            <a:r>
+              <a:rPr sz="1200" b="1" i="0">
+                <a:solidFill>
+                  <a:srgbClr val="E8590C"/>
+                </a:solidFill>
+                <a:latin typeface="Calibri"/>
+              </a:rPr>
+              <a:t>PRECISA DE CONTEXTO PRÉVIO</a:t>
+            </a:r>
+          </a:p>
+        </p:txBody>
+      </p:sp>
+      <p:sp>
+        <p:nvSpPr>
+          <p:cNvPr id="6" name="TextBox 6"/>
+          <p:cNvSpPr txBox="1"/>
+          <p:nvPr/>
+        </p:nvSpPr>
+        <p:spPr>
+          <a:xfrm>
+            <a:off x="914400" y="2331720"/>
+            <a:ext cx="4663440" cy="365760"/>
+          </a:xfrm>
+          <a:prstGeom prst="rect">
+            <a:avLst/>
+          </a:prstGeom>
+          <a:noFill/>
+        </p:spPr>
+        <p:txBody>
+          <a:bodyPr wrap="square" lIns="0" rIns="0" tIns="0" bIns="0">
+            <a:spAutoFit/>
+          </a:bodyPr>
+          <a:lstStyle/>
+          <a:p>
+            <a:pPr algn="l"/>
+            <a:r>
+              <a:rPr sz="1450" b="1" i="0">
+                <a:solidFill>
+                  <a:srgbClr val="1B2A4A"/>
+                </a:solidFill>
+                <a:latin typeface="Calibri"/>
+              </a:rPr>
+              <a:t>6 de 12 pares do piloto</a:t>
+            </a:r>
+          </a:p>
+        </p:txBody>
+      </p:sp>
+      <p:sp>
+        <p:nvSpPr>
+          <p:cNvPr id="7" name="TextBox 7"/>
+          <p:cNvSpPr txBox="1"/>
+          <p:nvPr/>
+        </p:nvSpPr>
+        <p:spPr>
+          <a:xfrm>
+            <a:off x="914400" y="2770632"/>
+            <a:ext cx="4663440" cy="777240"/>
+          </a:xfrm>
+          <a:prstGeom prst="rect">
+            <a:avLst/>
+          </a:prstGeom>
+          <a:noFill/>
+        </p:spPr>
+        <p:txBody>
+          <a:bodyPr wrap="square" lIns="0" rIns="0" tIns="0" bIns="0">
+            <a:spAutoFit/>
+          </a:bodyPr>
+          <a:lstStyle/>
+          <a:p>
+            <a:pPr algn="l">
+              <a:lnSpc>
+                <a:spcPct val="110000"/>
+              </a:lnSpc>
+            </a:pPr>
+            <a:r>
+              <a:rPr sz="1200" b="0" i="1">
+                <a:solidFill>
+                  <a:srgbClr val="495057"/>
+                </a:solidFill>
+                <a:latin typeface="Calibri"/>
+              </a:rPr>
+              <a:t>Ex.: “Mas ainda...” (Vieira), apóstrofe a “tu, feto esquecido” (Anjos), elisão “(...)” (Andrade)</a:t>
+            </a:r>
+          </a:p>
+        </p:txBody>
+      </p:sp>
+      <p:sp>
+        <p:nvSpPr>
+          <p:cNvPr id="8" name="TextBox 8"/>
+          <p:cNvSpPr txBox="1"/>
+          <p:nvPr/>
+        </p:nvSpPr>
+        <p:spPr>
+          <a:xfrm>
+            <a:off x="914400" y="3593592"/>
+            <a:ext cx="4663440" cy="548640"/>
+          </a:xfrm>
+          <a:prstGeom prst="rect">
+            <a:avLst/>
+          </a:prstGeom>
+          <a:noFill/>
+        </p:spPr>
+        <p:txBody>
+          <a:bodyPr wrap="square" lIns="0" rIns="0" tIns="0" bIns="0">
+            <a:spAutoFit/>
+          </a:bodyPr>
+          <a:lstStyle/>
+          <a:p>
+            <a:pPr algn="l">
+              <a:lnSpc>
+                <a:spcPct val="110000"/>
+              </a:lnSpc>
+            </a:pPr>
+            <a:r>
+              <a:rPr sz="1200" b="0" i="0">
+                <a:solidFill>
+                  <a:srgbClr val="495057"/>
+                </a:solidFill>
+                <a:latin typeface="Calibri"/>
+              </a:rPr>
+              <a:t>→ conectivo, dêixis ou apóstrofe sem antecedente dentro do trecho</a:t>
+            </a:r>
+          </a:p>
+        </p:txBody>
+      </p:sp>
+      <p:sp>
+        <p:nvSpPr>
+          <p:cNvPr id="9" name="Rounded Rectangle 9"/>
+          <p:cNvSpPr/>
+          <p:nvPr/>
+        </p:nvSpPr>
+        <p:spPr>
+          <a:xfrm>
+            <a:off x="914400" y="4297680"/>
+            <a:ext cx="4663440" cy="256032"/>
+          </a:xfrm>
+          <a:prstGeom prst="roundRect">
+            <a:avLst>
+              <a:gd name="adj" fmla="val 50000"/>
+            </a:avLst>
+          </a:prstGeom>
+          <a:solidFill>
+            <a:srgbClr val="E9ECEF"/>
+          </a:solidFill>
+          <a:ln>
+            <a:noFill/>
+          </a:ln>
+          <a:effectLst/>
+        </p:spPr>
+        <p:style>
+          <a:lnRef idx="1">
+            <a:schemeClr val="accent1"/>
+          </a:lnRef>
+          <a:fillRef idx="3">
+            <a:schemeClr val="accent1"/>
+          </a:fillRef>
+          <a:effectRef idx="2">
+            <a:schemeClr val="accent1"/>
+          </a:effectRef>
+          <a:fontRef idx="minor">
+            <a:schemeClr val="lt1"/>
+          </a:fontRef>
+        </p:style>
+        <p:txBody>
+          <a:bodyPr rtlCol="0" anchor="ctr"/>
+          <a:lstStyle/>
+          <a:p>
+            <a:pPr algn="ctr"/>
+          </a:p>
+        </p:txBody>
+      </p:sp>
+      <p:sp>
+        <p:nvSpPr>
+          <p:cNvPr id="10" name="Rounded Rectangle 10"/>
+          <p:cNvSpPr/>
+          <p:nvPr/>
+        </p:nvSpPr>
+        <p:spPr>
+          <a:xfrm>
+            <a:off x="914400" y="4297680"/>
+            <a:ext cx="2665524" cy="256032"/>
+          </a:xfrm>
+          <a:prstGeom prst="roundRect">
+            <a:avLst>
+              <a:gd name="adj" fmla="val 50000"/>
+            </a:avLst>
+          </a:prstGeom>
+          <a:solidFill>
+            <a:srgbClr val="E8590C"/>
+          </a:solidFill>
+          <a:ln>
+            <a:noFill/>
+          </a:ln>
+          <a:effectLst/>
+        </p:spPr>
+        <p:style>
+          <a:lnRef idx="1">
+            <a:schemeClr val="accent1"/>
+          </a:lnRef>
+          <a:fillRef idx="3">
+            <a:schemeClr val="accent1"/>
+          </a:fillRef>
+          <a:effectRef idx="2">
+            <a:schemeClr val="accent1"/>
+          </a:effectRef>
+          <a:fontRef idx="minor">
+            <a:schemeClr val="lt1"/>
+          </a:fontRef>
+        </p:style>
+        <p:txBody>
+          <a:bodyPr rtlCol="0" anchor="ctr"/>
+          <a:lstStyle/>
+          <a:p>
+            <a:pPr algn="ctr"/>
+          </a:p>
+        </p:txBody>
+      </p:sp>
+      <p:sp>
+        <p:nvSpPr>
+          <p:cNvPr id="11" name="TextBox 11"/>
+          <p:cNvSpPr txBox="1"/>
+          <p:nvPr/>
+        </p:nvSpPr>
+        <p:spPr>
+          <a:xfrm>
+            <a:off x="914400" y="4590288"/>
+            <a:ext cx="4663440" cy="274320"/>
+          </a:xfrm>
+          <a:prstGeom prst="rect">
+            <a:avLst/>
+          </a:prstGeom>
+          <a:noFill/>
+        </p:spPr>
+        <p:txBody>
+          <a:bodyPr wrap="square" lIns="0" rIns="0" tIns="0" bIns="0">
+            <a:spAutoFit/>
+          </a:bodyPr>
+          <a:lstStyle/>
+          <a:p>
+            <a:pPr algn="l"/>
+            <a:r>
+              <a:rPr sz="1250" b="1" i="0">
+                <a:solidFill>
+                  <a:srgbClr val="E8590C"/>
+                </a:solidFill>
+                <a:latin typeface="Calibri"/>
+              </a:rPr>
+              <a:t>similaridade média ≈ 0,57</a:t>
+            </a:r>
+          </a:p>
+        </p:txBody>
+      </p:sp>
+      <p:sp>
+        <p:nvSpPr>
+          <p:cNvPr id="12" name="Rounded Rectangle 12"/>
+          <p:cNvSpPr/>
+          <p:nvPr/>
+        </p:nvSpPr>
+        <p:spPr>
+          <a:xfrm>
+            <a:off x="6309360" y="1600200"/>
+            <a:ext cx="5212080" cy="3246120"/>
+          </a:xfrm>
+          <a:prstGeom prst="roundRect">
+            <a:avLst>
+              <a:gd name="adj" fmla="val 6000"/>
+            </a:avLst>
+          </a:prstGeom>
+          <a:solidFill>
+            <a:srgbClr val="F6F7F9"/>
+          </a:solidFill>
+          <a:ln>
+            <a:noFill/>
+          </a:ln>
+          <a:effectLst/>
+        </p:spPr>
+        <p:style>
+          <a:lnRef idx="1">
+            <a:schemeClr val="accent1"/>
+          </a:lnRef>
+          <a:fillRef idx="3">
+            <a:schemeClr val="accent1"/>
+          </a:fillRef>
+          <a:effectRef idx="2">
+            <a:schemeClr val="accent1"/>
+          </a:effectRef>
+          <a:fontRef idx="minor">
+            <a:schemeClr val="lt1"/>
+          </a:fontRef>
+        </p:style>
+        <p:txBody>
+          <a:bodyPr rtlCol="0" anchor="ctr"/>
+          <a:lstStyle/>
+          <a:p>
+            <a:pPr algn="ctr"/>
+          </a:p>
+        </p:txBody>
+      </p:sp>
+      <p:sp>
+        <p:nvSpPr>
+          <p:cNvPr id="13" name="Rounded Rectangle 13"/>
+          <p:cNvSpPr/>
+          <p:nvPr/>
+        </p:nvSpPr>
+        <p:spPr>
+          <a:xfrm>
+            <a:off x="6583680" y="1856232"/>
+            <a:ext cx="1900000" cy="365760"/>
+          </a:xfrm>
+          <a:prstGeom prst="roundRect">
+            <a:avLst>
+              <a:gd name="adj" fmla="val 50000"/>
+            </a:avLst>
+          </a:prstGeom>
+          <a:solidFill>
+            <a:srgbClr val="DFF6EE"/>
+          </a:solidFill>
+          <a:ln>
+            <a:noFill/>
+          </a:ln>
+          <a:effectLst/>
+        </p:spPr>
+        <p:style>
+          <a:lnRef idx="1">
+            <a:schemeClr val="accent1"/>
+          </a:lnRef>
+          <a:fillRef idx="3">
+            <a:schemeClr val="accent1"/>
+          </a:fillRef>
+          <a:effectRef idx="2">
+            <a:schemeClr val="accent1"/>
+          </a:effectRef>
+          <a:fontRef idx="minor">
+            <a:schemeClr val="lt1"/>
+          </a:fontRef>
+        </p:style>
+        <p:txBody>
+          <a:bodyPr rtlCol="0" anchor="ctr" wrap="square" lIns="228600" rIns="228600"/>
+          <a:lstStyle/>
+          <a:p>
+            <a:pPr algn="ctr"/>
+            <a:r>
+              <a:rPr sz="1200" b="1" i="0">
+                <a:solidFill>
+                  <a:srgbClr val="0CA678"/>
+                </a:solidFill>
+                <a:latin typeface="Calibri"/>
+              </a:rPr>
+              <a:t>AUTOCONTIDO</a:t>
+            </a:r>
+          </a:p>
+        </p:txBody>
+      </p:sp>
+      <p:sp>
+        <p:nvSpPr>
+          <p:cNvPr id="14" name="TextBox 14"/>
+          <p:cNvSpPr txBox="1"/>
+          <p:nvPr/>
+        </p:nvSpPr>
+        <p:spPr>
+          <a:xfrm>
+            <a:off x="6583680" y="2331720"/>
+            <a:ext cx="4663440" cy="365760"/>
+          </a:xfrm>
+          <a:prstGeom prst="rect">
+            <a:avLst/>
+          </a:prstGeom>
+          <a:noFill/>
+        </p:spPr>
+        <p:txBody>
+          <a:bodyPr wrap="square" lIns="0" rIns="0" tIns="0" bIns="0">
+            <a:spAutoFit/>
+          </a:bodyPr>
+          <a:lstStyle/>
+          <a:p>
+            <a:pPr algn="l"/>
+            <a:r>
+              <a:rPr sz="1450" b="1" i="0">
+                <a:solidFill>
+                  <a:srgbClr val="1B2A4A"/>
+                </a:solidFill>
+                <a:latin typeface="Calibri"/>
+              </a:rPr>
+              <a:t>6 de 12 pares do piloto</a:t>
+            </a:r>
+          </a:p>
+        </p:txBody>
+      </p:sp>
+      <p:sp>
+        <p:nvSpPr>
+          <p:cNvPr id="15" name="TextBox 15"/>
+          <p:cNvSpPr txBox="1"/>
+          <p:nvPr/>
+        </p:nvSpPr>
+        <p:spPr>
+          <a:xfrm>
+            <a:off x="6583680" y="2770632"/>
+            <a:ext cx="4663440" cy="777240"/>
+          </a:xfrm>
+          <a:prstGeom prst="rect">
+            <a:avLst/>
+          </a:prstGeom>
+          <a:noFill/>
+        </p:spPr>
+        <p:txBody>
+          <a:bodyPr wrap="square" lIns="0" rIns="0" tIns="0" bIns="0">
+            <a:spAutoFit/>
+          </a:bodyPr>
+          <a:lstStyle/>
+          <a:p>
+            <a:pPr algn="l">
+              <a:lnSpc>
+                <a:spcPct val="110000"/>
+              </a:lnSpc>
+            </a:pPr>
+            <a:r>
+              <a:rPr sz="1200" b="0" i="1">
+                <a:solidFill>
+                  <a:srgbClr val="495057"/>
+                </a:solidFill>
+                <a:latin typeface="Calibri"/>
+              </a:rPr>
+              <a:t>Ex.: Rubião (Assis), Miranda (Azevedo), Macunaíma (Andrade)</a:t>
+            </a:r>
+          </a:p>
+        </p:txBody>
+      </p:sp>
+      <p:sp>
+        <p:nvSpPr>
+          <p:cNvPr id="16" name="TextBox 16"/>
+          <p:cNvSpPr txBox="1"/>
+          <p:nvPr/>
+        </p:nvSpPr>
+        <p:spPr>
+          <a:xfrm>
+            <a:off x="6583680" y="3593592"/>
+            <a:ext cx="4663440" cy="548640"/>
+          </a:xfrm>
+          <a:prstGeom prst="rect">
+            <a:avLst/>
+          </a:prstGeom>
+          <a:noFill/>
+        </p:spPr>
+        <p:txBody>
+          <a:bodyPr wrap="square" lIns="0" rIns="0" tIns="0" bIns="0">
+            <a:spAutoFit/>
+          </a:bodyPr>
+          <a:lstStyle/>
+          <a:p>
+            <a:pPr algn="l">
+              <a:lnSpc>
+                <a:spcPct val="110000"/>
+              </a:lnSpc>
+            </a:pPr>
+            <a:r>
+              <a:rPr sz="1200" b="0" i="0">
+                <a:solidFill>
+                  <a:srgbClr val="495057"/>
+                </a:solidFill>
+                <a:latin typeface="Calibri"/>
+              </a:rPr>
+              <a:t>→ personagem e cena descritos dentro da própria frase</a:t>
+            </a:r>
+          </a:p>
+        </p:txBody>
+      </p:sp>
+      <p:sp>
+        <p:nvSpPr>
+          <p:cNvPr id="17" name="Rounded Rectangle 17"/>
+          <p:cNvSpPr/>
+          <p:nvPr/>
+        </p:nvSpPr>
+        <p:spPr>
+          <a:xfrm>
+            <a:off x="6583680" y="4297680"/>
+            <a:ext cx="4663440" cy="256032"/>
+          </a:xfrm>
+          <a:prstGeom prst="roundRect">
+            <a:avLst>
+              <a:gd name="adj" fmla="val 50000"/>
+            </a:avLst>
+          </a:prstGeom>
+          <a:solidFill>
+            <a:srgbClr val="E9ECEF"/>
+          </a:solidFill>
+          <a:ln>
+            <a:noFill/>
+          </a:ln>
+          <a:effectLst/>
+        </p:spPr>
+        <p:style>
+          <a:lnRef idx="1">
+            <a:schemeClr val="accent1"/>
+          </a:lnRef>
+          <a:fillRef idx="3">
+            <a:schemeClr val="accent1"/>
+          </a:fillRef>
+          <a:effectRef idx="2">
+            <a:schemeClr val="accent1"/>
+          </a:effectRef>
+          <a:fontRef idx="minor">
+            <a:schemeClr val="lt1"/>
+          </a:fontRef>
+        </p:style>
+        <p:txBody>
+          <a:bodyPr rtlCol="0" anchor="ctr"/>
+          <a:lstStyle/>
+          <a:p>
+            <a:pPr algn="ctr"/>
+          </a:p>
+        </p:txBody>
+      </p:sp>
+      <p:sp>
+        <p:nvSpPr>
+          <p:cNvPr id="18" name="Rounded Rectangle 18"/>
+          <p:cNvSpPr/>
+          <p:nvPr/>
+        </p:nvSpPr>
+        <p:spPr>
+          <a:xfrm>
+            <a:off x="6583680" y="4297680"/>
+            <a:ext cx="3421309" cy="256032"/>
+          </a:xfrm>
+          <a:prstGeom prst="roundRect">
+            <a:avLst>
+              <a:gd name="adj" fmla="val 50000"/>
+            </a:avLst>
+          </a:prstGeom>
+          <a:solidFill>
+            <a:srgbClr val="0CA678"/>
+          </a:solidFill>
+          <a:ln>
+            <a:noFill/>
+          </a:ln>
+          <a:effectLst/>
+        </p:spPr>
+        <p:style>
+          <a:lnRef idx="1">
+            <a:schemeClr val="accent1"/>
+          </a:lnRef>
+          <a:fillRef idx="3">
+            <a:schemeClr val="accent1"/>
+          </a:fillRef>
+          <a:effectRef idx="2">
+            <a:schemeClr val="accent1"/>
+          </a:effectRef>
+          <a:fontRef idx="minor">
+            <a:schemeClr val="lt1"/>
+          </a:fontRef>
+        </p:style>
+        <p:txBody>
+          <a:bodyPr rtlCol="0" anchor="ctr"/>
+          <a:lstStyle/>
+          <a:p>
+            <a:pPr algn="ctr"/>
+          </a:p>
+        </p:txBody>
+      </p:sp>
+      <p:sp>
+        <p:nvSpPr>
+          <p:cNvPr id="19" name="TextBox 19"/>
+          <p:cNvSpPr txBox="1"/>
+          <p:nvPr/>
+        </p:nvSpPr>
+        <p:spPr>
+          <a:xfrm>
+            <a:off x="6583680" y="4590288"/>
+            <a:ext cx="4663440" cy="274320"/>
+          </a:xfrm>
+          <a:prstGeom prst="rect">
+            <a:avLst/>
+          </a:prstGeom>
+          <a:noFill/>
+        </p:spPr>
+        <p:txBody>
+          <a:bodyPr wrap="square" lIns="0" rIns="0" tIns="0" bIns="0">
+            <a:spAutoFit/>
+          </a:bodyPr>
+          <a:lstStyle/>
+          <a:p>
+            <a:pPr algn="l"/>
+            <a:r>
+              <a:rPr sz="1250" b="1" i="0">
+                <a:solidFill>
+                  <a:srgbClr val="0CA678"/>
+                </a:solidFill>
+                <a:latin typeface="Calibri"/>
+              </a:rPr>
+              <a:t>similaridade média ≈ 0,73</a:t>
+            </a:r>
+          </a:p>
+        </p:txBody>
+      </p:sp>
+      <p:sp>
+        <p:nvSpPr>
+          <p:cNvPr id="20" name="Rounded Rectangle 20"/>
+          <p:cNvSpPr/>
+          <p:nvPr/>
+        </p:nvSpPr>
+        <p:spPr>
+          <a:xfrm>
+            <a:off x="640080" y="5532120"/>
+            <a:ext cx="10911535" cy="777240"/>
+          </a:xfrm>
+          <a:prstGeom prst="roundRect">
+            <a:avLst>
+              <a:gd name="adj" fmla="val 10000"/>
+            </a:avLst>
+          </a:prstGeom>
+          <a:solidFill>
+            <a:srgbClr val="E7ECFC"/>
+          </a:solidFill>
+          <a:ln>
+            <a:noFill/>
+          </a:ln>
+          <a:effectLst/>
+        </p:spPr>
+        <p:style>
+          <a:lnRef idx="1">
+            <a:schemeClr val="accent1"/>
+          </a:lnRef>
+          <a:fillRef idx="3">
+            <a:schemeClr val="accent1"/>
+          </a:fillRef>
+          <a:effectRef idx="2">
+            <a:schemeClr val="accent1"/>
+          </a:effectRef>
+          <a:fontRef idx="minor">
+            <a:schemeClr val="lt1"/>
+          </a:fontRef>
+        </p:style>
+        <p:txBody>
+          <a:bodyPr rtlCol="0" anchor="ctr" wrap="square" lIns="320040" rIns="320040"/>
+          <a:lstStyle/>
+          <a:p>
+            <a:pPr algn="l">
+              <a:lnSpc>
+                <a:spcPct val="115000"/>
+              </a:lnSpc>
+            </a:pPr>
+            <a:r>
+              <a:rPr sz="1300" b="0" i="1">
+                <a:solidFill>
+                  <a:srgbClr val="1B2A4A"/>
+                </a:solidFill>
+                <a:latin typeface="Calibri"/>
+              </a:rPr>
+              <a:t>5 dos 6 pares “Lógico-pragmática” (Seção 6) também precisam de contexto prévio, contra 1 dos 5 “Lexical/Retórica” — os dois fatores estão praticamente confundidos neste piloto (Mann-Whitney p ≈ 0,004). Ainda não dá para saber se é o fenômeno ou o contexto perdido que reduz a similaridade.</a:t>
+            </a:r>
+          </a:p>
+        </p:txBody>
+      </p:sp>
+      <p:sp>
+        <p:nvSpPr>
+          <p:cNvPr id="21" name="TextBox 21"/>
+          <p:cNvSpPr txBox="1"/>
+          <p:nvPr/>
+        </p:nvSpPr>
+        <p:spPr>
+          <a:xfrm>
+            <a:off x="640080" y="6400800"/>
+            <a:ext cx="5486400" cy="320040"/>
+          </a:xfrm>
+          <a:prstGeom prst="rect">
+            <a:avLst/>
+          </a:prstGeom>
+          <a:noFill/>
+        </p:spPr>
+        <p:txBody>
+          <a:bodyPr wrap="square" lIns="0" rIns="0" tIns="0" bIns="0">
+            <a:spAutoFit/>
+          </a:bodyPr>
+          <a:lstStyle/>
+          <a:p>
+            <a:pPr algn="l"/>
+            <a:r>
+              <a:rPr sz="1000" b="0" i="0">
+                <a:solidFill>
+                  <a:srgbClr val="868E96"/>
+                </a:solidFill>
+                <a:latin typeface="Calibri"/>
+              </a:rPr>
+              <a:t>Laboratório de Estresse Semântico</a:t>
+            </a:r>
+          </a:p>
+        </p:txBody>
+      </p:sp>
+      <p:sp>
+        <p:nvSpPr>
+          <p:cNvPr id="22" name="TextBox 22"/>
+          <p:cNvSpPr txBox="1"/>
+          <p:nvPr/>
+        </p:nvSpPr>
+        <p:spPr>
+          <a:xfrm>
+            <a:off x="10637215" y="6400800"/>
+            <a:ext cx="914400" cy="320040"/>
+          </a:xfrm>
+          <a:prstGeom prst="rect">
+            <a:avLst/>
+          </a:prstGeom>
+          <a:noFill/>
+        </p:spPr>
+        <p:txBody>
+          <a:bodyPr wrap="square" lIns="0" rIns="0" tIns="0" bIns="0">
+            <a:spAutoFit/>
+          </a:bodyPr>
+          <a:lstStyle/>
+          <a:p>
+            <a:pPr algn="r"/>
+            <a:r>
+              <a:rPr sz="1000" b="0" i="0">
+                <a:solidFill>
+                  <a:srgbClr val="868E96"/>
+                </a:solidFill>
+                <a:latin typeface="Calibri"/>
+              </a:rPr>
+              <a:t>10</a:t>
+            </a:r>
+          </a:p>
+        </p:txBody>
+      </p:sp>
+    </p:spTree>
+  </p:cSld>
+  <p:clrMapOvr>
+    <a:masterClrMapping/>
+  </p:clrMapOvr>
+</p:sld>
+</file>
+
+<file path=ppt/slides/slide12.xml><?xml version="1.0" encoding="utf-8"?>
+<p:sld xmlns:a="http://schemas.openxmlformats.org/drawingml/2006/main" xmlns:p="http://schemas.openxmlformats.org/presentationml/2006/main" xmlns:r="http://schemas.openxmlformats.org/officeDocument/2006/relationships">
+  <p:cSld>
+    <p:bg>
+      <p:bgPr>
+        <a:solidFill>
+          <a:srgbClr val="FFFFFF"/>
+        </a:solidFill>
+        <a:effectLst/>
+      </p:bgPr>
+    </p:bg>
+    <p:spTree>
+      <p:nvGrpSpPr>
+        <p:cNvPr id="1" name=""/>
+        <p:cNvGrpSpPr/>
+        <p:nvPr/>
+      </p:nvGrpSpPr>
+      <p:grpSpPr/>
+      <p:sp>
+        <p:nvSpPr>
+          <p:cNvPr id="2" name="TextBox 23"/>
+          <p:cNvSpPr txBox="1"/>
+          <p:nvPr/>
+        </p:nvSpPr>
+        <p:spPr>
+          <a:xfrm>
+            <a:off x="640080" y="411480"/>
+            <a:ext cx="10911535" cy="320040"/>
+          </a:xfrm>
+          <a:prstGeom prst="rect">
+            <a:avLst/>
+          </a:prstGeom>
+          <a:noFill/>
+        </p:spPr>
+        <p:txBody>
+          <a:bodyPr wrap="square" lIns="0" rIns="0" tIns="0" bIns="0">
+            <a:spAutoFit/>
+          </a:bodyPr>
+          <a:lstStyle/>
+          <a:p>
+            <a:pPr algn="l"/>
+            <a:r>
+              <a:rPr sz="1200" b="1" i="0">
+                <a:solidFill>
+                  <a:srgbClr val="3B5BDB"/>
+                </a:solidFill>
+                <a:latin typeface="Calibri"/>
+              </a:rPr>
+              <a:t>ATUALIZAÇÃO (n=25)</a:t>
+            </a:r>
+          </a:p>
+        </p:txBody>
+      </p:sp>
+      <p:sp>
+        <p:nvSpPr>
+          <p:cNvPr id="3" name="TextBox 24"/>
+          <p:cNvSpPr txBox="1"/>
+          <p:nvPr/>
+        </p:nvSpPr>
+        <p:spPr>
+          <a:xfrm>
+            <a:off x="640080" y="777240"/>
+            <a:ext cx="10911535" cy="731520"/>
+          </a:xfrm>
+          <a:prstGeom prst="rect">
+            <a:avLst/>
+          </a:prstGeom>
+          <a:noFill/>
+        </p:spPr>
+        <p:txBody>
+          <a:bodyPr wrap="square" lIns="0" rIns="0" tIns="0" bIns="0">
+            <a:spAutoFit/>
+          </a:bodyPr>
+          <a:lstStyle/>
+          <a:p>
+            <a:pPr algn="l"/>
+            <a:r>
+              <a:rPr sz="3000" b="1" i="0">
+                <a:solidFill>
+                  <a:srgbClr val="1B2A4A"/>
+                </a:solidFill>
+                <a:latin typeface="Calibri"/>
+              </a:rPr>
+              <a:t>A hierarquia “Paradoxo pior” não se sustentou</a:t>
+            </a:r>
+          </a:p>
+        </p:txBody>
+      </p:sp>
+      <p:sp>
+        <p:nvSpPr>
+          <p:cNvPr id="4" name="Rounded Rectangle 4"/>
+          <p:cNvSpPr/>
+          <p:nvPr/>
+        </p:nvSpPr>
+        <p:spPr>
+          <a:xfrm>
+            <a:off x="640080" y="1600200"/>
+            <a:ext cx="5212080" cy="3246120"/>
+          </a:xfrm>
+          <a:prstGeom prst="roundRect">
+            <a:avLst>
+              <a:gd name="adj" fmla="val 6000"/>
+            </a:avLst>
+          </a:prstGeom>
+          <a:solidFill>
+            <a:srgbClr val="F6F7F9"/>
+          </a:solidFill>
+          <a:ln>
+            <a:noFill/>
+          </a:ln>
+          <a:effectLst/>
+        </p:spPr>
+        <p:style>
+          <a:lnRef idx="1">
+            <a:schemeClr val="accent1"/>
+          </a:lnRef>
+          <a:fillRef idx="3">
+            <a:schemeClr val="accent1"/>
+          </a:fillRef>
+          <a:effectRef idx="2">
+            <a:schemeClr val="accent1"/>
+          </a:effectRef>
+          <a:fontRef idx="minor">
+            <a:schemeClr val="lt1"/>
+          </a:fontRef>
+        </p:style>
+        <p:txBody>
+          <a:bodyPr rtlCol="0" anchor="ctr"/>
+          <a:lstStyle/>
+          <a:p>
+            <a:pPr algn="ctr"/>
+          </a:p>
+        </p:txBody>
+      </p:sp>
+      <p:sp>
+        <p:nvSpPr>
+          <p:cNvPr id="5" name="Rounded Rectangle 5"/>
+          <p:cNvSpPr/>
+          <p:nvPr/>
+        </p:nvSpPr>
+        <p:spPr>
+          <a:xfrm>
+            <a:off x="914400" y="1856232"/>
+            <a:ext cx="3450000" cy="365760"/>
+          </a:xfrm>
+          <a:prstGeom prst="roundRect">
+            <a:avLst>
+              <a:gd name="adj" fmla="val 50000"/>
+            </a:avLst>
+          </a:prstGeom>
+          <a:solidFill>
+            <a:srgbClr val="FDECE0"/>
+          </a:solidFill>
+          <a:ln>
+            <a:noFill/>
+          </a:ln>
+          <a:effectLst/>
+        </p:spPr>
+        <p:style>
+          <a:lnRef idx="1">
+            <a:schemeClr val="accent1"/>
+          </a:lnRef>
+          <a:fillRef idx="3">
+            <a:schemeClr val="accent1"/>
+          </a:fillRef>
+          <a:effectRef idx="2">
+            <a:schemeClr val="accent1"/>
+          </a:effectRef>
+          <a:fontRef idx="minor">
+            <a:schemeClr val="lt1"/>
+          </a:fontRef>
+        </p:style>
+        <p:txBody>
+          <a:bodyPr rtlCol="0" anchor="ctr" wrap="square" lIns="228600" rIns="228600"/>
+          <a:lstStyle/>
+          <a:p>
+            <a:pPr algn="ctr"/>
+            <a:r>
+              <a:rPr sz="1200" b="1" i="0">
+                <a:solidFill>
+                  <a:srgbClr val="E8590C"/>
+                </a:solidFill>
+                <a:latin typeface="Calibri"/>
+              </a:rPr>
+              <a:t>PARADOXO — SÓ n=1 (PILOTO)</a:t>
+            </a:r>
+          </a:p>
+        </p:txBody>
+      </p:sp>
+      <p:sp>
+        <p:nvSpPr>
+          <p:cNvPr id="6" name="TextBox 6"/>
+          <p:cNvSpPr txBox="1"/>
+          <p:nvPr/>
+        </p:nvSpPr>
+        <p:spPr>
+          <a:xfrm>
+            <a:off x="914400" y="2331720"/>
+            <a:ext cx="4663440" cy="365760"/>
+          </a:xfrm>
+          <a:prstGeom prst="rect">
+            <a:avLst/>
+          </a:prstGeom>
+          <a:noFill/>
+        </p:spPr>
+        <p:txBody>
+          <a:bodyPr wrap="square" lIns="0" rIns="0" tIns="0" bIns="0">
+            <a:spAutoFit/>
+          </a:bodyPr>
+          <a:lstStyle/>
+          <a:p>
+            <a:pPr algn="l"/>
+            <a:r>
+              <a:rPr sz="1450" b="1" i="0">
+                <a:solidFill>
+                  <a:srgbClr val="1B2A4A"/>
+                </a:solidFill>
+                <a:latin typeface="Calibri"/>
+              </a:rPr>
+              <a:t>vieira_002, o único par do piloto</a:t>
+            </a:r>
+          </a:p>
+        </p:txBody>
+      </p:sp>
+      <p:sp>
+        <p:nvSpPr>
+          <p:cNvPr id="7" name="TextBox 7"/>
+          <p:cNvSpPr txBox="1"/>
+          <p:nvPr/>
+        </p:nvSpPr>
+        <p:spPr>
+          <a:xfrm>
+            <a:off x="914400" y="2770632"/>
+            <a:ext cx="4663440" cy="777240"/>
+          </a:xfrm>
+          <a:prstGeom prst="rect">
+            <a:avLst/>
+          </a:prstGeom>
+          <a:noFill/>
+        </p:spPr>
+        <p:txBody>
+          <a:bodyPr wrap="square" lIns="0" rIns="0" tIns="0" bIns="0">
+            <a:spAutoFit/>
+          </a:bodyPr>
+          <a:lstStyle/>
+          <a:p>
+            <a:pPr algn="l">
+              <a:lnSpc>
+                <a:spcPct val="110000"/>
+              </a:lnSpc>
+            </a:pPr>
+            <a:r>
+              <a:rPr sz="1200" b="0" i="1">
+                <a:solidFill>
+                  <a:srgbClr val="495057"/>
+                </a:solidFill>
+                <a:latin typeface="Calibri"/>
+              </a:rPr>
+              <a:t>Ex.: “É uma arte sem arte, caia onde cair” (Vieira)</a:t>
+            </a:r>
+          </a:p>
+        </p:txBody>
+      </p:sp>
+      <p:sp>
+        <p:nvSpPr>
+          <p:cNvPr id="8" name="TextBox 8"/>
+          <p:cNvSpPr txBox="1"/>
+          <p:nvPr/>
+        </p:nvSpPr>
+        <p:spPr>
+          <a:xfrm>
+            <a:off x="914400" y="3593592"/>
+            <a:ext cx="4663440" cy="548640"/>
+          </a:xfrm>
+          <a:prstGeom prst="rect">
+            <a:avLst/>
+          </a:prstGeom>
+          <a:noFill/>
+        </p:spPr>
+        <p:txBody>
+          <a:bodyPr wrap="square" lIns="0" rIns="0" tIns="0" bIns="0">
+            <a:spAutoFit/>
+          </a:bodyPr>
+          <a:lstStyle/>
+          <a:p>
+            <a:pPr algn="l">
+              <a:lnSpc>
+                <a:spcPct val="110000"/>
+              </a:lnSpc>
+            </a:pPr>
+            <a:r>
+              <a:rPr sz="1200" b="0" i="0">
+                <a:solidFill>
+                  <a:srgbClr val="495057"/>
+                </a:solidFill>
+                <a:latin typeface="Calibri"/>
+              </a:rPr>
+              <a:t>→ parecia o fenômeno mais hostil aos embeddings do dataset</a:t>
+            </a:r>
+          </a:p>
+        </p:txBody>
+      </p:sp>
+      <p:sp>
+        <p:nvSpPr>
+          <p:cNvPr id="9" name="Rounded Rectangle 9"/>
+          <p:cNvSpPr/>
+          <p:nvPr/>
+        </p:nvSpPr>
+        <p:spPr>
+          <a:xfrm>
+            <a:off x="914400" y="4297680"/>
+            <a:ext cx="4663440" cy="256032"/>
+          </a:xfrm>
+          <a:prstGeom prst="roundRect">
+            <a:avLst>
+              <a:gd name="adj" fmla="val 50000"/>
+            </a:avLst>
+          </a:prstGeom>
+          <a:solidFill>
+            <a:srgbClr val="E9ECEF"/>
+          </a:solidFill>
+          <a:ln>
+            <a:noFill/>
+          </a:ln>
+          <a:effectLst/>
+        </p:spPr>
+        <p:style>
+          <a:lnRef idx="1">
+            <a:schemeClr val="accent1"/>
+          </a:lnRef>
+          <a:fillRef idx="3">
+            <a:schemeClr val="accent1"/>
+          </a:fillRef>
+          <a:effectRef idx="2">
+            <a:schemeClr val="accent1"/>
+          </a:effectRef>
+          <a:fontRef idx="minor">
+            <a:schemeClr val="lt1"/>
+          </a:fontRef>
+        </p:style>
+        <p:txBody>
+          <a:bodyPr rtlCol="0" anchor="ctr"/>
+          <a:lstStyle/>
+          <a:p>
+            <a:pPr algn="ctr"/>
+          </a:p>
+        </p:txBody>
+      </p:sp>
+      <p:sp>
+        <p:nvSpPr>
+          <p:cNvPr id="10" name="Rounded Rectangle 10"/>
+          <p:cNvSpPr/>
+          <p:nvPr/>
+        </p:nvSpPr>
+        <p:spPr>
+          <a:xfrm>
+            <a:off x="914400" y="4297680"/>
+            <a:ext cx="1818742" cy="256032"/>
+          </a:xfrm>
+          <a:prstGeom prst="roundRect">
+            <a:avLst>
+              <a:gd name="adj" fmla="val 50000"/>
+            </a:avLst>
+          </a:prstGeom>
+          <a:solidFill>
+            <a:srgbClr val="E8590C"/>
+          </a:solidFill>
+          <a:ln>
+            <a:noFill/>
+          </a:ln>
+          <a:effectLst/>
+        </p:spPr>
+        <p:style>
+          <a:lnRef idx="1">
+            <a:schemeClr val="accent1"/>
+          </a:lnRef>
+          <a:fillRef idx="3">
+            <a:schemeClr val="accent1"/>
+          </a:fillRef>
+          <a:effectRef idx="2">
+            <a:schemeClr val="accent1"/>
+          </a:effectRef>
+          <a:fontRef idx="minor">
+            <a:schemeClr val="lt1"/>
+          </a:fontRef>
+        </p:style>
+        <p:txBody>
+          <a:bodyPr rtlCol="0" anchor="ctr"/>
+          <a:lstStyle/>
+          <a:p>
+            <a:pPr algn="ctr"/>
+          </a:p>
+        </p:txBody>
+      </p:sp>
+      <p:sp>
+        <p:nvSpPr>
+          <p:cNvPr id="11" name="TextBox 11"/>
+          <p:cNvSpPr txBox="1"/>
+          <p:nvPr/>
+        </p:nvSpPr>
+        <p:spPr>
+          <a:xfrm>
+            <a:off x="914400" y="4590288"/>
+            <a:ext cx="4663440" cy="274320"/>
+          </a:xfrm>
+          <a:prstGeom prst="rect">
+            <a:avLst/>
+          </a:prstGeom>
+          <a:noFill/>
+        </p:spPr>
+        <p:txBody>
+          <a:bodyPr wrap="square" lIns="0" rIns="0" tIns="0" bIns="0">
+            <a:spAutoFit/>
+          </a:bodyPr>
+          <a:lstStyle/>
+          <a:p>
+            <a:pPr algn="l"/>
+            <a:r>
+              <a:rPr sz="1250" b="1" i="0">
+                <a:solidFill>
+                  <a:srgbClr val="E8590C"/>
+                </a:solidFill>
+                <a:latin typeface="Calibri"/>
+              </a:rPr>
+              <a:t>similaridade ≈ 0,39 (mínimo do piloto)</a:t>
+            </a:r>
+          </a:p>
+        </p:txBody>
+      </p:sp>
+      <p:sp>
+        <p:nvSpPr>
+          <p:cNvPr id="12" name="Rounded Rectangle 12"/>
+          <p:cNvSpPr/>
+          <p:nvPr/>
+        </p:nvSpPr>
+        <p:spPr>
+          <a:xfrm>
+            <a:off x="6309360" y="1600200"/>
+            <a:ext cx="5212080" cy="3246120"/>
+          </a:xfrm>
+          <a:prstGeom prst="roundRect">
+            <a:avLst>
+              <a:gd name="adj" fmla="val 6000"/>
+            </a:avLst>
+          </a:prstGeom>
+          <a:solidFill>
+            <a:srgbClr val="F6F7F9"/>
+          </a:solidFill>
+          <a:ln>
+            <a:noFill/>
+          </a:ln>
+          <a:effectLst/>
+        </p:spPr>
+        <p:style>
+          <a:lnRef idx="1">
+            <a:schemeClr val="accent1"/>
+          </a:lnRef>
+          <a:fillRef idx="3">
+            <a:schemeClr val="accent1"/>
+          </a:fillRef>
+          <a:effectRef idx="2">
+            <a:schemeClr val="accent1"/>
+          </a:effectRef>
+          <a:fontRef idx="minor">
+            <a:schemeClr val="lt1"/>
+          </a:fontRef>
+        </p:style>
+        <p:txBody>
+          <a:bodyPr rtlCol="0" anchor="ctr"/>
+          <a:lstStyle/>
+          <a:p>
+            <a:pPr algn="ctr"/>
+          </a:p>
+        </p:txBody>
+      </p:sp>
+      <p:sp>
+        <p:nvSpPr>
+          <p:cNvPr id="13" name="Rounded Rectangle 13"/>
+          <p:cNvSpPr/>
+          <p:nvPr/>
+        </p:nvSpPr>
+        <p:spPr>
+          <a:xfrm>
+            <a:off x="6583680" y="1856232"/>
+            <a:ext cx="1900000" cy="365760"/>
+          </a:xfrm>
+          <a:prstGeom prst="roundRect">
+            <a:avLst>
+              <a:gd name="adj" fmla="val 50000"/>
+            </a:avLst>
+          </a:prstGeom>
+          <a:solidFill>
+            <a:srgbClr val="DFF6EE"/>
+          </a:solidFill>
+          <a:ln>
+            <a:noFill/>
+          </a:ln>
+          <a:effectLst/>
+        </p:spPr>
+        <p:style>
+          <a:lnRef idx="1">
+            <a:schemeClr val="accent1"/>
+          </a:lnRef>
+          <a:fillRef idx="3">
+            <a:schemeClr val="accent1"/>
+          </a:fillRef>
+          <a:effectRef idx="2">
+            <a:schemeClr val="accent1"/>
+          </a:effectRef>
+          <a:fontRef idx="minor">
+            <a:schemeClr val="lt1"/>
+          </a:fontRef>
+        </p:style>
+        <p:txBody>
+          <a:bodyPr rtlCol="0" anchor="ctr" wrap="square" lIns="228600" rIns="228600"/>
+          <a:lstStyle/>
+          <a:p>
+            <a:pPr algn="ctr"/>
+            <a:r>
+              <a:rPr sz="1200" b="1" i="0">
+                <a:solidFill>
+                  <a:srgbClr val="0CA678"/>
+                </a:solidFill>
+                <a:latin typeface="Calibri"/>
+              </a:rPr>
+              <a:t>PARADOXO — AGORA n=4</a:t>
+            </a:r>
+          </a:p>
+        </p:txBody>
+      </p:sp>
+      <p:sp>
+        <p:nvSpPr>
+          <p:cNvPr id="14" name="TextBox 14"/>
+          <p:cNvSpPr txBox="1"/>
+          <p:nvPr/>
+        </p:nvSpPr>
+        <p:spPr>
+          <a:xfrm>
+            <a:off x="6583680" y="2331720"/>
+            <a:ext cx="4663440" cy="365760"/>
+          </a:xfrm>
+          <a:prstGeom prst="rect">
+            <a:avLst/>
+          </a:prstGeom>
+          <a:noFill/>
+        </p:spPr>
+        <p:txBody>
+          <a:bodyPr wrap="square" lIns="0" rIns="0" tIns="0" bIns="0">
+            <a:spAutoFit/>
+          </a:bodyPr>
+          <a:lstStyle/>
+          <a:p>
+            <a:pPr algn="l"/>
+            <a:r>
+              <a:rPr sz="1450" b="1" i="0">
+                <a:solidFill>
+                  <a:srgbClr val="1B2A4A"/>
+                </a:solidFill>
+                <a:latin typeface="Calibri"/>
+              </a:rPr>
+              <a:t>+ Camões e 2 sonetos de Gregório de Matos</a:t>
+            </a:r>
+          </a:p>
+        </p:txBody>
+      </p:sp>
+      <p:sp>
+        <p:nvSpPr>
+          <p:cNvPr id="15" name="TextBox 15"/>
+          <p:cNvSpPr txBox="1"/>
+          <p:nvPr/>
+        </p:nvSpPr>
+        <p:spPr>
+          <a:xfrm>
+            <a:off x="6583680" y="2770632"/>
+            <a:ext cx="4663440" cy="777240"/>
+          </a:xfrm>
+          <a:prstGeom prst="rect">
+            <a:avLst/>
+          </a:prstGeom>
+          <a:noFill/>
+        </p:spPr>
+        <p:txBody>
+          <a:bodyPr wrap="square" lIns="0" rIns="0" tIns="0" bIns="0">
+            <a:spAutoFit/>
+          </a:bodyPr>
+          <a:lstStyle/>
+          <a:p>
+            <a:pPr algn="l">
+              <a:lnSpc>
+                <a:spcPct val="110000"/>
+              </a:lnSpc>
+            </a:pPr>
+            <a:r>
+              <a:rPr sz="1200" b="0" i="1">
+                <a:solidFill>
+                  <a:srgbClr val="495057"/>
+                </a:solidFill>
+                <a:latin typeface="Calibri"/>
+              </a:rPr>
+              <a:t>Ex.: matos_001 chega a 0,89 — o maior valor do dataset inteiro</a:t>
+            </a:r>
+          </a:p>
+        </p:txBody>
+      </p:sp>
+      <p:sp>
+        <p:nvSpPr>
+          <p:cNvPr id="16" name="TextBox 16"/>
+          <p:cNvSpPr txBox="1"/>
+          <p:nvPr/>
+        </p:nvSpPr>
+        <p:spPr>
+          <a:xfrm>
+            <a:off x="6583680" y="3593592"/>
+            <a:ext cx="4663440" cy="548640"/>
+          </a:xfrm>
+          <a:prstGeom prst="rect">
+            <a:avLst/>
+          </a:prstGeom>
+          <a:noFill/>
+        </p:spPr>
+        <p:txBody>
+          <a:bodyPr wrap="square" lIns="0" rIns="0" tIns="0" bIns="0">
+            <a:spAutoFit/>
+          </a:bodyPr>
+          <a:lstStyle/>
+          <a:p>
+            <a:pPr algn="l">
+              <a:lnSpc>
+                <a:spcPct val="110000"/>
+              </a:lnSpc>
+            </a:pPr>
+            <a:r>
+              <a:rPr sz="1200" b="0" i="0">
+                <a:solidFill>
+                  <a:srgbClr val="495057"/>
+                </a:solidFill>
+                <a:latin typeface="Calibri"/>
+              </a:rPr>
+              <a:t>→ virou o fenômeno de MAIOR desvio padrão, não o de menor média</a:t>
+            </a:r>
+          </a:p>
+        </p:txBody>
+      </p:sp>
+      <p:sp>
+        <p:nvSpPr>
+          <p:cNvPr id="17" name="Rounded Rectangle 17"/>
+          <p:cNvSpPr/>
+          <p:nvPr/>
+        </p:nvSpPr>
+        <p:spPr>
+          <a:xfrm>
+            <a:off x="6583680" y="4297680"/>
+            <a:ext cx="4663440" cy="256032"/>
+          </a:xfrm>
+          <a:prstGeom prst="roundRect">
+            <a:avLst>
+              <a:gd name="adj" fmla="val 50000"/>
+            </a:avLst>
+          </a:prstGeom>
+          <a:solidFill>
+            <a:srgbClr val="E9ECEF"/>
+          </a:solidFill>
+          <a:ln>
+            <a:noFill/>
+          </a:ln>
+          <a:effectLst/>
+        </p:spPr>
+        <p:style>
+          <a:lnRef idx="1">
+            <a:schemeClr val="accent1"/>
+          </a:lnRef>
+          <a:fillRef idx="3">
+            <a:schemeClr val="accent1"/>
+          </a:fillRef>
+          <a:effectRef idx="2">
+            <a:schemeClr val="accent1"/>
+          </a:effectRef>
+          <a:fontRef idx="minor">
+            <a:schemeClr val="lt1"/>
+          </a:fontRef>
+        </p:style>
+        <p:txBody>
+          <a:bodyPr rtlCol="0" anchor="ctr"/>
+          <a:lstStyle/>
+          <a:p>
+            <a:pPr algn="ctr"/>
+          </a:p>
+        </p:txBody>
+      </p:sp>
+      <p:sp>
+        <p:nvSpPr>
+          <p:cNvPr id="18" name="Rounded Rectangle 18"/>
+          <p:cNvSpPr/>
+          <p:nvPr/>
+        </p:nvSpPr>
+        <p:spPr>
+          <a:xfrm>
+            <a:off x="6583680" y="4297680"/>
+            <a:ext cx="3684118" cy="256032"/>
+          </a:xfrm>
+          <a:prstGeom prst="roundRect">
+            <a:avLst>
+              <a:gd name="adj" fmla="val 50000"/>
+            </a:avLst>
+          </a:prstGeom>
+          <a:solidFill>
+            <a:srgbClr val="0CA678"/>
+          </a:solidFill>
+          <a:ln>
+            <a:noFill/>
+          </a:ln>
+          <a:effectLst/>
+        </p:spPr>
+        <p:style>
+          <a:lnRef idx="1">
+            <a:schemeClr val="accent1"/>
+          </a:lnRef>
+          <a:fillRef idx="3">
+            <a:schemeClr val="accent1"/>
+          </a:fillRef>
+          <a:effectRef idx="2">
+            <a:schemeClr val="accent1"/>
+          </a:effectRef>
+          <a:fontRef idx="minor">
+            <a:schemeClr val="lt1"/>
+          </a:fontRef>
+        </p:style>
+        <p:txBody>
+          <a:bodyPr rtlCol="0" anchor="ctr"/>
+          <a:lstStyle/>
+          <a:p>
+            <a:pPr algn="ctr"/>
+          </a:p>
+        </p:txBody>
+      </p:sp>
+      <p:sp>
+        <p:nvSpPr>
+          <p:cNvPr id="19" name="TextBox 19"/>
+          <p:cNvSpPr txBox="1"/>
+          <p:nvPr/>
+        </p:nvSpPr>
+        <p:spPr>
+          <a:xfrm>
+            <a:off x="6583680" y="4590288"/>
+            <a:ext cx="4663440" cy="274320"/>
+          </a:xfrm>
+          <a:prstGeom prst="rect">
+            <a:avLst/>
+          </a:prstGeom>
+          <a:noFill/>
+        </p:spPr>
+        <p:txBody>
+          <a:bodyPr wrap="square" lIns="0" rIns="0" tIns="0" bIns="0">
+            <a:spAutoFit/>
+          </a:bodyPr>
+          <a:lstStyle/>
+          <a:p>
+            <a:pPr algn="l"/>
+            <a:r>
+              <a:rPr sz="1250" b="1" i="0">
+                <a:solidFill>
+                  <a:srgbClr val="0CA678"/>
+                </a:solidFill>
+                <a:latin typeface="Calibri"/>
+              </a:rPr>
+              <a:t>similaridade média ≈ 0,79 (DP 0,19–0,28)</a:t>
+            </a:r>
+          </a:p>
+        </p:txBody>
+      </p:sp>
+      <p:sp>
+        <p:nvSpPr>
+          <p:cNvPr id="20" name="Rounded Rectangle 20"/>
+          <p:cNvSpPr/>
+          <p:nvPr/>
+        </p:nvSpPr>
+        <p:spPr>
+          <a:xfrm>
+            <a:off x="640080" y="5532120"/>
+            <a:ext cx="10911535" cy="777240"/>
+          </a:xfrm>
+          <a:prstGeom prst="roundRect">
+            <a:avLst>
+              <a:gd name="adj" fmla="val 10000"/>
+            </a:avLst>
+          </a:prstGeom>
+          <a:solidFill>
+            <a:srgbClr val="E7ECFC"/>
+          </a:solidFill>
+          <a:ln>
+            <a:noFill/>
+          </a:ln>
+          <a:effectLst/>
+        </p:spPr>
+        <p:style>
+          <a:lnRef idx="1">
+            <a:schemeClr val="accent1"/>
+          </a:lnRef>
+          <a:fillRef idx="3">
+            <a:schemeClr val="accent1"/>
+          </a:fillRef>
+          <a:effectRef idx="2">
+            <a:schemeClr val="accent1"/>
+          </a:effectRef>
+          <a:fontRef idx="minor">
+            <a:schemeClr val="lt1"/>
+          </a:fontRef>
+        </p:style>
+        <p:txBody>
+          <a:bodyPr rtlCol="0" anchor="ctr" wrap="square" lIns="320040" rIns="320040"/>
+          <a:lstStyle/>
+          <a:p>
+            <a:pPr algn="l">
+              <a:lnSpc>
+                <a:spcPct val="115000"/>
+              </a:lnSpc>
+            </a:pPr>
+            <a:r>
+              <a:rPr sz="1300" b="0" i="1">
+                <a:solidFill>
+                  <a:srgbClr val="1B2A4A"/>
+                </a:solidFill>
+                <a:latin typeface="Calibri"/>
+              </a:rPr>
+              <a:t>O extremo “Paradoxo é o pior fenômeno” não se sustentou: era uma leitura de vieira_002 especificamente (também dependente de contexto — slide anterior), não do fenômeno em si. O confound de contexto segue significativo com n=25 (Mann-Whitney p ≈ 0,016).</a:t>
+            </a:r>
+          </a:p>
+        </p:txBody>
+      </p:sp>
+      <p:sp>
+        <p:nvSpPr>
+          <p:cNvPr id="21" name="TextBox 21"/>
+          <p:cNvSpPr txBox="1"/>
+          <p:nvPr/>
+        </p:nvSpPr>
+        <p:spPr>
+          <a:xfrm>
+            <a:off x="640080" y="6400800"/>
+            <a:ext cx="5486400" cy="320040"/>
+          </a:xfrm>
+          <a:prstGeom prst="rect">
+            <a:avLst/>
+          </a:prstGeom>
+          <a:noFill/>
+        </p:spPr>
+        <p:txBody>
+          <a:bodyPr wrap="square" lIns="0" rIns="0" tIns="0" bIns="0">
+            <a:spAutoFit/>
+          </a:bodyPr>
+          <a:lstStyle/>
+          <a:p>
+            <a:pPr algn="l"/>
+            <a:r>
+              <a:rPr sz="1000" b="0" i="0">
+                <a:solidFill>
+                  <a:srgbClr val="868E96"/>
+                </a:solidFill>
+                <a:latin typeface="Calibri"/>
+              </a:rPr>
+              <a:t>Laboratório de Estresse Semântico</a:t>
+            </a:r>
+          </a:p>
+        </p:txBody>
+      </p:sp>
+      <p:sp>
+        <p:nvSpPr>
+          <p:cNvPr id="22" name="TextBox 22"/>
+          <p:cNvSpPr txBox="1"/>
+          <p:nvPr/>
+        </p:nvSpPr>
+        <p:spPr>
+          <a:xfrm>
+            <a:off x="10637215" y="6400800"/>
+            <a:ext cx="914400" cy="320040"/>
+          </a:xfrm>
+          <a:prstGeom prst="rect">
+            <a:avLst/>
+          </a:prstGeom>
+          <a:noFill/>
+        </p:spPr>
+        <p:txBody>
+          <a:bodyPr wrap="square" lIns="0" rIns="0" tIns="0" bIns="0">
+            <a:spAutoFit/>
+          </a:bodyPr>
+          <a:lstStyle/>
+          <a:p>
+            <a:pPr algn="r"/>
+            <a:r>
+              <a:rPr sz="1000" b="0" i="0">
+                <a:solidFill>
+                  <a:srgbClr val="868E96"/>
+                </a:solidFill>
+                <a:latin typeface="Calibri"/>
+              </a:rPr>
+              <a:t>11</a:t>
+            </a:r>
+          </a:p>
+        </p:txBody>
+      </p:sp>
+    </p:spTree>
+  </p:cSld>
+  <p:clrMapOvr>
+    <a:masterClrMapping/>
+  </p:clrMapOvr>
+</p:sld>
+</file>
+
 <file path=ppt/slides/slide2.xml><?xml version="1.0" encoding="utf-8"?>
 <p:sld xmlns:a="http://schemas.openxmlformats.org/drawingml/2006/main" xmlns:p="http://schemas.openxmlformats.org/presentationml/2006/main" xmlns:r="http://schemas.openxmlformats.org/officeDocument/2006/relationships">
   <p:cSld>
@@ -4000,7 +6431,7 @@
                 </a:solidFill>
                 <a:latin typeface="Calibri"/>
               </a:rPr>
-              <a:t>2</a:t>
+              <a:t>3</a:t>
             </a:r>
           </a:p>
         </p:txBody>
@@ -4837,7 +7268,7 @@
                 </a:solidFill>
                 <a:latin typeface="Calibri"/>
               </a:rPr>
-              <a:t>3</a:t>
+              <a:t>4</a:t>
             </a:r>
           </a:p>
         </p:txBody>
@@ -5536,7 +7967,7 @@
                 </a:solidFill>
                 <a:latin typeface="Calibri"/>
               </a:rPr>
-              <a:t>4</a:t>
+              <a:t>5</a:t>
             </a:r>
           </a:p>
         </p:txBody>
@@ -6419,7 +8850,7 @@
                 </a:solidFill>
                 <a:latin typeface="Calibri"/>
               </a:rPr>
-              <a:t>5</a:t>
+              <a:t>8</a:t>
             </a:r>
           </a:p>
         </p:txBody>
@@ -6954,7 +9385,7 @@
                 </a:solidFill>
                 <a:latin typeface="Calibri"/>
               </a:rPr>
-              <a:t>6</a:t>
+              <a:t>9</a:t>
             </a:r>
           </a:p>
         </p:txBody>
@@ -7070,7 +9501,7 @@
             <a:avLst/>
           </a:prstGeom>
           <a:solidFill>
-            <a:srgbClr val="3B5BDB"/>
+            <a:srgbClr val="0CA678"/>
           </a:solidFill>
           <a:ln>
             <a:noFill/>
@@ -7138,7 +9569,7 @@
                 </a:solidFill>
                 <a:latin typeface="Calibri"/>
               </a:rPr>
-              <a:t>Expandir o dataset</a:t>
+              <a:t>Expandir o dataset (concluído)</a:t>
             </a:r>
           </a:p>
         </p:txBody>
@@ -7177,7 +9608,7 @@
                 </a:solidFill>
                 <a:latin typeface="Calibri"/>
               </a:rPr>
-              <a:t>Mais exemplos por fenômeno linguístico, além do piloto atual (12 pares).</a:t>
+              <a:t>Dataset ampliado de 12 para 25 pares — mais Camões, Gregório de Matos, Machado de Assis e Fernando Pessoa/Ricardo Reis (Seção 8 do notebook).</a:t>
             </a:r>
           </a:p>
         </p:txBody>
@@ -7503,7 +9934,7 @@
                 </a:solidFill>
                 <a:latin typeface="Calibri"/>
               </a:rPr>
-              <a:t>Comparações consistentes por categoria de fenômeno, com significância estatística.</a:t>
+              <a:t>Com n=25, Paradoxo, Antítese, Hipérbato e Zeugma já têm múltiplas observações (Seção 8) — e a hierarquia original não se sustentou. Falta balancear autocontido/dependente de contexto dentro de cada fenômeno para separar os dois efeitos.</a:t>
             </a:r>
           </a:p>
         </p:txBody>
@@ -7573,7 +10004,1152 @@
                 </a:solidFill>
                 <a:latin typeface="Calibri"/>
               </a:rPr>
-              <a:t>7</a:t>
+              <a:t>12</a:t>
+            </a:r>
+          </a:p>
+        </p:txBody>
+      </p:sp>
+    </p:spTree>
+  </p:cSld>
+  <p:clrMapOvr>
+    <a:masterClrMapping/>
+  </p:clrMapOvr>
+</p:sld>
+</file>
+
+<file path=ppt/slides/slide8.xml><?xml version="1.0" encoding="utf-8"?>
+<p:sld xmlns:a="http://schemas.openxmlformats.org/drawingml/2006/main" xmlns:p="http://schemas.openxmlformats.org/presentationml/2006/main" xmlns:r="http://schemas.openxmlformats.org/officeDocument/2006/relationships">
+  <p:cSld>
+    <p:bg>
+      <p:bgPr>
+        <a:solidFill>
+          <a:srgbClr val="FFFFFF"/>
+        </a:solidFill>
+        <a:effectLst/>
+      </p:bgPr>
+    </p:bg>
+    <p:spTree>
+      <p:nvGrpSpPr>
+        <p:cNvPr id="1" name=""/>
+        <p:cNvGrpSpPr/>
+        <p:nvPr/>
+      </p:nvGrpSpPr>
+      <p:grpSpPr/>
+      <p:sp>
+        <p:nvSpPr>
+          <p:cNvPr id="2" name="TextBox 2"/>
+          <p:cNvSpPr txBox="1"/>
+          <p:nvPr/>
+        </p:nvSpPr>
+        <p:spPr>
+          <a:xfrm>
+            <a:off x="640080" y="411480"/>
+            <a:ext cx="10911535" cy="320040"/>
+          </a:xfrm>
+          <a:prstGeom prst="rect">
+            <a:avLst/>
+          </a:prstGeom>
+          <a:noFill/>
+        </p:spPr>
+        <p:txBody>
+          <a:bodyPr wrap="square" lIns="0" rIns="0" tIns="0" bIns="0">
+            <a:spAutoFit/>
+          </a:bodyPr>
+          <a:lstStyle/>
+          <a:p>
+            <a:pPr algn="l"/>
+            <a:r>
+              <a:rPr sz="1200" b="1" i="0">
+                <a:solidFill>
+                  <a:srgbClr val="3B5BDB"/>
+                </a:solidFill>
+                <a:latin typeface="Calibri"/>
+              </a:rPr>
+              <a:t>ORIGEM</a:t>
+            </a:r>
+          </a:p>
+        </p:txBody>
+      </p:sp>
+      <p:sp>
+        <p:nvSpPr>
+          <p:cNvPr id="3" name="TextBox 3"/>
+          <p:cNvSpPr txBox="1"/>
+          <p:nvPr/>
+        </p:nvSpPr>
+        <p:spPr>
+          <a:xfrm>
+            <a:off x="640080" y="777240"/>
+            <a:ext cx="10911535" cy="731520"/>
+          </a:xfrm>
+          <a:prstGeom prst="rect">
+            <a:avLst/>
+          </a:prstGeom>
+          <a:noFill/>
+        </p:spPr>
+        <p:txBody>
+          <a:bodyPr wrap="square" lIns="0" rIns="0" tIns="0" bIns="0">
+            <a:spAutoFit/>
+          </a:bodyPr>
+          <a:lstStyle/>
+          <a:p>
+            <a:pPr algn="l"/>
+            <a:r>
+              <a:rPr sz="3000" b="1" i="0">
+                <a:solidFill>
+                  <a:srgbClr val="1B2A4A"/>
+                </a:solidFill>
+                <a:latin typeface="Calibri"/>
+              </a:rPr>
+              <a:t>De onde veio a ideia</a:t>
+            </a:r>
+          </a:p>
+        </p:txBody>
+      </p:sp>
+      <p:sp>
+        <p:nvSpPr>
+          <p:cNvPr id="4" name="Ring"/>
+          <p:cNvSpPr/>
+          <p:nvPr/>
+        </p:nvSpPr>
+        <p:spPr>
+          <a:xfrm>
+            <a:off x="1463040" y="1508760"/>
+            <a:ext cx="3383280" cy="3383280"/>
+          </a:xfrm>
+          <a:prstGeom prst="ellipse">
+            <a:avLst/>
+          </a:prstGeom>
+          <a:solidFill>
+            <a:srgbClr val="E7ECFC"/>
+          </a:solidFill>
+          <a:ln>
+            <a:noFill/>
+          </a:ln>
+          <a:effectLst/>
+        </p:spPr>
+        <p:style>
+          <a:lnRef idx="1">
+            <a:schemeClr val="accent1"/>
+          </a:lnRef>
+          <a:fillRef idx="3">
+            <a:schemeClr val="accent1"/>
+          </a:fillRef>
+          <a:effectRef idx="2">
+            <a:schemeClr val="accent1"/>
+          </a:effectRef>
+          <a:fontRef idx="minor">
+            <a:schemeClr val="lt1"/>
+          </a:fontRef>
+        </p:style>
+        <p:txBody>
+          <a:bodyPr rtlCol="0" anchor="ctr"/>
+          <a:lstStyle/>
+          <a:p>
+            <a:pPr algn="ctr"/>
+          </a:p>
+        </p:txBody>
+      </p:sp>
+      <p:pic>
+        <p:nvPicPr>
+          <p:cNvPr id="5" name="Foto Bruna Martiolli"/>
+          <p:cNvPicPr>
+            <a:picLocks noChangeAspect="1"/>
+          </p:cNvPicPr>
+          <p:nvPr/>
+        </p:nvPicPr>
+        <p:blipFill>
+          <a:blip r:embed="rId2"/>
+          <a:stretch>
+            <a:fillRect/>
+          </a:stretch>
+        </p:blipFill>
+        <p:spPr>
+          <a:xfrm>
+            <a:off x="1554480" y="1600200"/>
+            <a:ext cx="3200400" cy="3200400"/>
+          </a:xfrm>
+          <a:prstGeom prst="ellipse">
+            <a:avLst/>
+          </a:prstGeom>
+          <a:ln w="38100">
+            <a:solidFill>
+              <a:srgbClr val="FFFFFF"/>
+            </a:solidFill>
+          </a:ln>
+          <a:effectLst/>
+        </p:spPr>
+      </p:pic>
+      <p:sp>
+        <p:nvSpPr>
+          <p:cNvPr id="6" name="TextBox 6"/>
+          <p:cNvSpPr txBox="1"/>
+          <p:nvPr/>
+        </p:nvSpPr>
+        <p:spPr>
+          <a:xfrm>
+            <a:off x="640080" y="5029200"/>
+            <a:ext cx="5029200" cy="640080"/>
+          </a:xfrm>
+          <a:prstGeom prst="rect">
+            <a:avLst/>
+          </a:prstGeom>
+          <a:noFill/>
+        </p:spPr>
+        <p:txBody>
+          <a:bodyPr wrap="square" lIns="0" rIns="0" tIns="0" bIns="0">
+            <a:spAutoFit/>
+          </a:bodyPr>
+          <a:lstStyle/>
+          <a:p>
+            <a:pPr algn="ctr">
+              <a:lnSpc>
+                <a:spcPct val="115000"/>
+              </a:lnSpc>
+            </a:pPr>
+            <a:r>
+              <a:rPr sz="1600" b="1" i="0">
+                <a:solidFill>
+                  <a:srgbClr val="1B2A4A"/>
+                </a:solidFill>
+                <a:latin typeface="Calibri"/>
+              </a:rPr>
+              <a:t>Bruna Martiolli</a:t>
+            </a:r>
+          </a:p>
+          <a:p>
+            <a:pPr algn="ctr">
+              <a:lnSpc>
+                <a:spcPct val="115000"/>
+              </a:lnSpc>
+              <a:spcBef>
+                <a:spcPts val="1300"/>
+              </a:spcBef>
+            </a:pPr>
+            <a:r>
+              <a:rPr sz="1250" b="0" i="0">
+                <a:solidFill>
+                  <a:srgbClr val="868E96"/>
+                </a:solidFill>
+                <a:latin typeface="Calibri"/>
+              </a:rPr>
+              <a:t>Professora de Literatura — doutoranda, pesquisa sobre Agustina Bessa-Luís</a:t>
+            </a:r>
+          </a:p>
+        </p:txBody>
+      </p:sp>
+      <p:sp>
+        <p:nvSpPr>
+          <p:cNvPr id="7" name="TextBox 7"/>
+          <p:cNvSpPr txBox="1"/>
+          <p:nvPr/>
+        </p:nvSpPr>
+        <p:spPr>
+          <a:xfrm>
+            <a:off x="6263640" y="1600200"/>
+            <a:ext cx="5212080" cy="3300000"/>
+          </a:xfrm>
+          <a:prstGeom prst="rect">
+            <a:avLst/>
+          </a:prstGeom>
+          <a:noFill/>
+        </p:spPr>
+        <p:txBody>
+          <a:bodyPr wrap="square" lIns="0" rIns="0" tIns="0" bIns="0">
+            <a:spAutoFit/>
+          </a:bodyPr>
+          <a:lstStyle/>
+          <a:p>
+            <a:pPr algn="l">
+              <a:lnSpc>
+                <a:spcPct val="115000"/>
+              </a:lnSpc>
+            </a:pPr>
+            <a:r>
+              <a:rPr sz="1500" b="0" i="0">
+                <a:solidFill>
+                  <a:srgbClr val="1B2A4A"/>
+                </a:solidFill>
+                <a:latin typeface="Calibri"/>
+              </a:rPr>
+              <a:t>Tudo começou ao assistir a um vídeo da professora de literatura Bruna Martiolli, que faz doutorado sobre Agustina Bessa-Luís.</a:t>
+            </a:r>
+          </a:p>
+          <a:p>
+            <a:pPr algn="l">
+              <a:lnSpc>
+                <a:spcPct val="115000"/>
+              </a:lnSpc>
+              <a:spcBef>
+                <a:spcPts val="1300"/>
+              </a:spcBef>
+            </a:pPr>
+            <a:r>
+              <a:rPr sz="1500" b="0" i="0">
+                <a:solidFill>
+                  <a:srgbClr val="495057"/>
+                </a:solidFill>
+                <a:latin typeface="Calibri"/>
+              </a:rPr>
+              <a:t>Ela comentou que tinha dificuldade em usar IA no seu trabalho: os modelos não conseguiam interpretar bem os textos literários complexos que ela analisa.</a:t>
+            </a:r>
+          </a:p>
+          <a:p>
+            <a:pPr algn="l">
+              <a:lnSpc>
+                <a:spcPct val="115000"/>
+              </a:lnSpc>
+              <a:spcBef>
+                <a:spcPts val="1300"/>
+              </a:spcBef>
+            </a:pPr>
+            <a:r>
+              <a:rPr sz="1500" b="0" i="0">
+                <a:solidFill>
+                  <a:srgbClr val="495057"/>
+                </a:solidFill>
+                <a:latin typeface="Calibri"/>
+              </a:rPr>
+              <a:t>Como, eu estava estudando embeddings — virou uma pergunta de pesquisa: será que uma frase complexa e sua versão simplificada, com o mesmo significado, ficam realmente próximas quando processadas por um modelo de embedding?</a:t>
+            </a:r>
+          </a:p>
+        </p:txBody>
+      </p:sp>
+      <p:sp>
+        <p:nvSpPr>
+          <p:cNvPr id="8" name="Rounded Rectangle 8"/>
+          <p:cNvSpPr/>
+          <p:nvPr/>
+        </p:nvSpPr>
+        <p:spPr>
+          <a:xfrm>
+            <a:off x="6263640" y="5532120"/>
+            <a:ext cx="5212080" cy="777240"/>
+          </a:xfrm>
+          <a:prstGeom prst="roundRect">
+            <a:avLst>
+              <a:gd name="adj" fmla="val 10000"/>
+            </a:avLst>
+          </a:prstGeom>
+          <a:solidFill>
+            <a:srgbClr val="E7ECFC"/>
+          </a:solidFill>
+          <a:ln>
+            <a:noFill/>
+          </a:ln>
+          <a:effectLst/>
+        </p:spPr>
+        <p:style>
+          <a:lnRef idx="1">
+            <a:schemeClr val="accent1"/>
+          </a:lnRef>
+          <a:fillRef idx="3">
+            <a:schemeClr val="accent1"/>
+          </a:fillRef>
+          <a:effectRef idx="2">
+            <a:schemeClr val="accent1"/>
+          </a:effectRef>
+          <a:fontRef idx="minor">
+            <a:schemeClr val="lt1"/>
+          </a:fontRef>
+        </p:style>
+        <p:txBody>
+          <a:bodyPr rtlCol="0" anchor="ctr" wrap="square" lIns="228600" rIns="228600"/>
+          <a:lstStyle/>
+          <a:p>
+            <a:pPr algn="l">
+              <a:lnSpc>
+                <a:spcPct val="112000"/>
+              </a:lnSpc>
+            </a:pPr>
+            <a:r>
+              <a:rPr sz="1400" b="0" i="1">
+                <a:solidFill>
+                  <a:srgbClr val="1B2A4A"/>
+                </a:solidFill>
+                <a:latin typeface="Calibri"/>
+              </a:rPr>
+              <a:t>Se o modelo de embedding realmente capturasse o sentido profundo, as duas versões deveriam ficar “próximas” no espaço vetorial, independente da complexidade da escrita.</a:t>
+            </a:r>
+          </a:p>
+        </p:txBody>
+      </p:sp>
+      <p:sp>
+        <p:nvSpPr>
+          <p:cNvPr id="9" name="TextBox 9"/>
+          <p:cNvSpPr txBox="1"/>
+          <p:nvPr/>
+        </p:nvSpPr>
+        <p:spPr>
+          <a:xfrm>
+            <a:off x="640080" y="6400800"/>
+            <a:ext cx="5486400" cy="320040"/>
+          </a:xfrm>
+          <a:prstGeom prst="rect">
+            <a:avLst/>
+          </a:prstGeom>
+          <a:noFill/>
+        </p:spPr>
+        <p:txBody>
+          <a:bodyPr wrap="square" lIns="0" rIns="0" tIns="0" bIns="0">
+            <a:spAutoFit/>
+          </a:bodyPr>
+          <a:lstStyle/>
+          <a:p>
+            <a:pPr algn="l"/>
+            <a:r>
+              <a:rPr sz="1000" b="0" i="0">
+                <a:solidFill>
+                  <a:srgbClr val="868E96"/>
+                </a:solidFill>
+                <a:latin typeface="Calibri"/>
+              </a:rPr>
+              <a:t>Laboratório de Estresse Semântico</a:t>
+            </a:r>
+          </a:p>
+        </p:txBody>
+      </p:sp>
+      <p:sp>
+        <p:nvSpPr>
+          <p:cNvPr id="10" name="TextBox 10"/>
+          <p:cNvSpPr txBox="1"/>
+          <p:nvPr/>
+        </p:nvSpPr>
+        <p:spPr>
+          <a:xfrm>
+            <a:off x="10637215" y="6400800"/>
+            <a:ext cx="914400" cy="320040"/>
+          </a:xfrm>
+          <a:prstGeom prst="rect">
+            <a:avLst/>
+          </a:prstGeom>
+          <a:noFill/>
+        </p:spPr>
+        <p:txBody>
+          <a:bodyPr wrap="square" lIns="0" rIns="0" tIns="0" bIns="0">
+            <a:spAutoFit/>
+          </a:bodyPr>
+          <a:lstStyle/>
+          <a:p>
+            <a:pPr algn="r"/>
+            <a:r>
+              <a:rPr sz="1000" b="0" i="0">
+                <a:solidFill>
+                  <a:srgbClr val="868E96"/>
+                </a:solidFill>
+                <a:latin typeface="Calibri"/>
+              </a:rPr>
+              <a:t>2</a:t>
+            </a:r>
+          </a:p>
+        </p:txBody>
+      </p:sp>
+    </p:spTree>
+  </p:cSld>
+  <p:clrMapOvr>
+    <a:masterClrMapping/>
+  </p:clrMapOvr>
+</p:sld>
+</file>
+
+<file path=ppt/slides/slide9.xml><?xml version="1.0" encoding="utf-8"?>
+<p:sld xmlns:a="http://schemas.openxmlformats.org/drawingml/2006/main" xmlns:p="http://schemas.openxmlformats.org/presentationml/2006/main" xmlns:r="http://schemas.openxmlformats.org/officeDocument/2006/relationships">
+  <p:cSld>
+    <p:bg>
+      <p:bgPr>
+        <a:solidFill>
+          <a:srgbClr val="FFFFFF"/>
+        </a:solidFill>
+        <a:effectLst/>
+      </p:bgPr>
+    </p:bg>
+    <p:spTree>
+      <p:nvGrpSpPr>
+        <p:cNvPr id="1" name=""/>
+        <p:cNvGrpSpPr/>
+        <p:nvPr/>
+      </p:nvGrpSpPr>
+      <p:grpSpPr/>
+      <p:sp>
+        <p:nvSpPr>
+          <p:cNvPr id="2" name="TextBox 2"/>
+          <p:cNvSpPr txBox="1"/>
+          <p:nvPr/>
+        </p:nvSpPr>
+        <p:spPr>
+          <a:xfrm>
+            <a:off x="640080" y="411480"/>
+            <a:ext cx="10911535" cy="320040"/>
+          </a:xfrm>
+          <a:prstGeom prst="rect">
+            <a:avLst/>
+          </a:prstGeom>
+          <a:noFill/>
+        </p:spPr>
+        <p:txBody>
+          <a:bodyPr wrap="square" lIns="0" rIns="0" tIns="0" bIns="0">
+            <a:spAutoFit/>
+          </a:bodyPr>
+          <a:lstStyle/>
+          <a:p>
+            <a:pPr algn="l"/>
+            <a:r>
+              <a:rPr sz="1200" b="1" i="0">
+                <a:solidFill>
+                  <a:srgbClr val="3B5BDB"/>
+                </a:solidFill>
+                <a:latin typeface="Calibri"/>
+              </a:rPr>
+              <a:t>MATEMÁTICA</a:t>
+            </a:r>
+          </a:p>
+        </p:txBody>
+      </p:sp>
+      <p:sp>
+        <p:nvSpPr>
+          <p:cNvPr id="3" name="TextBox 3"/>
+          <p:cNvSpPr txBox="1"/>
+          <p:nvPr/>
+        </p:nvSpPr>
+        <p:spPr>
+          <a:xfrm>
+            <a:off x="640080" y="777240"/>
+            <a:ext cx="10911535" cy="731520"/>
+          </a:xfrm>
+          <a:prstGeom prst="rect">
+            <a:avLst/>
+          </a:prstGeom>
+          <a:noFill/>
+        </p:spPr>
+        <p:txBody>
+          <a:bodyPr wrap="square" lIns="0" rIns="0" tIns="0" bIns="0">
+            <a:spAutoFit/>
+          </a:bodyPr>
+          <a:lstStyle/>
+          <a:p>
+            <a:pPr algn="l"/>
+            <a:r>
+              <a:rPr sz="3000" b="1" i="0">
+                <a:solidFill>
+                  <a:srgbClr val="1B2A4A"/>
+                </a:solidFill>
+                <a:latin typeface="Calibri"/>
+              </a:rPr>
+              <a:t>Como o cosseno mede a similaridade</a:t>
+            </a:r>
+          </a:p>
+        </p:txBody>
+      </p:sp>
+      <p:pic>
+        <p:nvPicPr>
+          <p:cNvPr id="4" name="Fórmula similaridade de cosseno"/>
+          <p:cNvPicPr>
+            <a:picLocks noChangeAspect="1"/>
+          </p:cNvPicPr>
+          <p:nvPr/>
+        </p:nvPicPr>
+        <p:blipFill>
+          <a:blip r:embed="rId2"/>
+          <a:stretch>
+            <a:fillRect/>
+          </a:stretch>
+        </p:blipFill>
+        <p:spPr>
+          <a:xfrm>
+            <a:off x="3495847" y="1706880"/>
+            <a:ext cx="5200000" cy="1315057"/>
+          </a:xfrm>
+          <a:prstGeom prst="rect">
+            <a:avLst/>
+          </a:prstGeom>
+          <a:effectLst/>
+        </p:spPr>
+      </p:pic>
+      <p:sp>
+        <p:nvSpPr>
+          <p:cNvPr id="5" name="TextBox 5"/>
+          <p:cNvSpPr txBox="1"/>
+          <p:nvPr/>
+        </p:nvSpPr>
+        <p:spPr>
+          <a:xfrm>
+            <a:off x="640080" y="3341977"/>
+            <a:ext cx="5029200" cy="2867920"/>
+          </a:xfrm>
+          <a:prstGeom prst="rect">
+            <a:avLst/>
+          </a:prstGeom>
+          <a:noFill/>
+        </p:spPr>
+        <p:txBody>
+          <a:bodyPr wrap="square" lIns="0" rIns="0" tIns="0" bIns="0">
+            <a:spAutoFit/>
+          </a:bodyPr>
+          <a:lstStyle/>
+          <a:p>
+            <a:pPr algn="l">
+              <a:lnSpc>
+                <a:spcPct val="112000"/>
+              </a:lnSpc>
+            </a:pPr>
+            <a:r>
+              <a:rPr sz="1300" b="1" i="0">
+                <a:solidFill>
+                  <a:srgbClr val="3B5BDB"/>
+                </a:solidFill>
+                <a:latin typeface="Calibri"/>
+              </a:rPr>
+              <a:t>●  </a:t>
+            </a:r>
+            <a:r>
+              <a:rPr sz="1400" b="1" i="0">
+                <a:solidFill>
+                  <a:srgbClr val="1B2A4A"/>
+                </a:solidFill>
+                <a:latin typeface="Calibri"/>
+              </a:rPr>
+              <a:t>A e B</a:t>
+            </a:r>
+            <a:r>
+              <a:rPr sz="1400" b="0" i="0">
+                <a:solidFill>
+                  <a:srgbClr val="495057"/>
+                </a:solidFill>
+                <a:latin typeface="Calibri"/>
+              </a:rPr>
+              <a:t> são os vetores (embeddings) dos dois textos sendo comparados.</a:t>
+            </a:r>
+          </a:p>
+          <a:p>
+            <a:pPr algn="l">
+              <a:lnSpc>
+                <a:spcPct val="112000"/>
+              </a:lnSpc>
+              <a:spcBef>
+                <a:spcPts val="1300"/>
+              </a:spcBef>
+            </a:pPr>
+            <a:r>
+              <a:rPr sz="1300" b="1" i="0">
+                <a:solidFill>
+                  <a:srgbClr val="3B5BDB"/>
+                </a:solidFill>
+                <a:latin typeface="Calibri"/>
+              </a:rPr>
+              <a:t>●  </a:t>
+            </a:r>
+            <a:r>
+              <a:rPr sz="1400" b="1" i="0">
+                <a:solidFill>
+                  <a:srgbClr val="1B2A4A"/>
+                </a:solidFill>
+                <a:latin typeface="Calibri"/>
+              </a:rPr>
+              <a:t>Numerador (A · B)</a:t>
+            </a:r>
+            <a:r>
+              <a:rPr sz="1400" b="0" i="0">
+                <a:solidFill>
+                  <a:srgbClr val="495057"/>
+                </a:solidFill>
+                <a:latin typeface="Calibri"/>
+              </a:rPr>
+              <a:t> é o produto escalar entre os vetores.</a:t>
+            </a:r>
+          </a:p>
+          <a:p>
+            <a:pPr algn="l">
+              <a:lnSpc>
+                <a:spcPct val="112000"/>
+              </a:lnSpc>
+              <a:spcBef>
+                <a:spcPts val="1300"/>
+              </a:spcBef>
+            </a:pPr>
+            <a:r>
+              <a:rPr sz="1300" b="1" i="0">
+                <a:solidFill>
+                  <a:srgbClr val="3B5BDB"/>
+                </a:solidFill>
+                <a:latin typeface="Calibri"/>
+              </a:rPr>
+              <a:t>●  </a:t>
+            </a:r>
+            <a:r>
+              <a:rPr sz="1400" b="1" i="0">
+                <a:solidFill>
+                  <a:srgbClr val="1B2A4A"/>
+                </a:solidFill>
+                <a:latin typeface="Calibri"/>
+              </a:rPr>
+              <a:t>Denominador (‖A‖ × ‖B‖)</a:t>
+            </a:r>
+            <a:r>
+              <a:rPr sz="1400" b="0" i="0">
+                <a:solidFill>
+                  <a:srgbClr val="495057"/>
+                </a:solidFill>
+                <a:latin typeface="Calibri"/>
+              </a:rPr>
+              <a:t> normaliza pelo tamanho (norma) de cada vetor.</a:t>
+            </a:r>
+          </a:p>
+          <a:p>
+            <a:pPr algn="l">
+              <a:lnSpc>
+                <a:spcPct val="112000"/>
+              </a:lnSpc>
+              <a:spcBef>
+                <a:spcPts val="1300"/>
+              </a:spcBef>
+            </a:pPr>
+            <a:r>
+              <a:rPr sz="1300" b="1" i="0">
+                <a:solidFill>
+                  <a:srgbClr val="3B5BDB"/>
+                </a:solidFill>
+                <a:latin typeface="Calibri"/>
+              </a:rPr>
+              <a:t>●  </a:t>
+            </a:r>
+            <a:r>
+              <a:rPr sz="1400" b="1" i="0">
+                <a:solidFill>
+                  <a:srgbClr val="1B2A4A"/>
+                </a:solidFill>
+                <a:latin typeface="Calibri"/>
+              </a:rPr>
+              <a:t>Resultado</a:t>
+            </a:r>
+            <a:r>
+              <a:rPr sz="1400" b="0" i="0">
+                <a:solidFill>
+                  <a:srgbClr val="495057"/>
+                </a:solidFill>
+                <a:latin typeface="Calibri"/>
+              </a:rPr>
+              <a:t> varia de −1 a 1: quanto mais perto de 1, mais “parecidos” os textos são; quanto mais perto de 0, mais diferentes.</a:t>
+            </a:r>
+          </a:p>
+        </p:txBody>
+      </p:sp>
+      <p:sp>
+        <p:nvSpPr>
+          <p:cNvPr id="6" name="Rounded Rectangle 6"/>
+          <p:cNvSpPr/>
+          <p:nvPr/>
+        </p:nvSpPr>
+        <p:spPr>
+          <a:xfrm>
+            <a:off x="6263640" y="3341977"/>
+            <a:ext cx="5212080" cy="2867920"/>
+          </a:xfrm>
+          <a:prstGeom prst="roundRect">
+            <a:avLst>
+              <a:gd name="adj" fmla="val 6000"/>
+            </a:avLst>
+          </a:prstGeom>
+          <a:solidFill>
+            <a:srgbClr val="F6F7F9"/>
+          </a:solidFill>
+          <a:ln>
+            <a:noFill/>
+          </a:ln>
+          <a:effectLst/>
+        </p:spPr>
+        <p:style>
+          <a:lnRef idx="1">
+            <a:schemeClr val="accent1"/>
+          </a:lnRef>
+          <a:fillRef idx="3">
+            <a:schemeClr val="accent1"/>
+          </a:fillRef>
+          <a:effectRef idx="2">
+            <a:schemeClr val="accent1"/>
+          </a:effectRef>
+          <a:fontRef idx="minor">
+            <a:schemeClr val="lt1"/>
+          </a:fontRef>
+        </p:style>
+        <p:txBody>
+          <a:bodyPr rtlCol="0" anchor="ctr"/>
+          <a:lstStyle/>
+          <a:p>
+            <a:pPr algn="ctr"/>
+          </a:p>
+        </p:txBody>
+      </p:sp>
+      <p:sp>
+        <p:nvSpPr>
+          <p:cNvPr id="7" name="TextBox 7"/>
+          <p:cNvSpPr txBox="1"/>
+          <p:nvPr/>
+        </p:nvSpPr>
+        <p:spPr>
+          <a:xfrm>
+            <a:off x="6492240" y="3524857"/>
+            <a:ext cx="4754880" cy="640080"/>
+          </a:xfrm>
+          <a:prstGeom prst="rect">
+            <a:avLst/>
+          </a:prstGeom>
+          <a:noFill/>
+        </p:spPr>
+        <p:txBody>
+          <a:bodyPr wrap="square" lIns="0" rIns="0" tIns="0" bIns="0">
+            <a:spAutoFit/>
+          </a:bodyPr>
+          <a:lstStyle/>
+          <a:p>
+            <a:pPr algn="ctr">
+              <a:lnSpc>
+                <a:spcPct val="115000"/>
+              </a:lnSpc>
+            </a:pPr>
+            <a:r>
+              <a:rPr sz="1250" b="0" i="1">
+                <a:solidFill>
+                  <a:srgbClr val="1B2A4A"/>
+                </a:solidFill>
+                <a:latin typeface="Calibri"/>
+              </a:rPr>
+              <a:t>Ângulo pequeno → maior similaridade  ·  ângulo grande → menor similaridade</a:t>
+            </a:r>
+          </a:p>
+        </p:txBody>
+      </p:sp>
+      <p:cxnSp>
+        <p:nvCxnSpPr>
+          <p:cNvPr id="8" name="Connector 8"/>
+          <p:cNvCxnSpPr/>
+          <p:nvPr/>
+        </p:nvCxnSpPr>
+        <p:spPr>
+          <a:xfrm flipV="1">
+            <a:off x="7163640" y="4312715"/>
+            <a:ext cx="1189157" cy="1417182"/>
+          </a:xfrm>
+          <a:prstGeom prst="line">
+            <a:avLst/>
+          </a:prstGeom>
+          <a:ln w="25400">
+            <a:solidFill>
+              <a:srgbClr val="1B2A4A"/>
+            </a:solidFill>
+            <a:tailEnd type="triangle" w="med" len="med"/>
+          </a:ln>
+        </p:spPr>
+        <p:style>
+          <a:lnRef idx="2">
+            <a:schemeClr val="accent1"/>
+          </a:lnRef>
+          <a:fillRef idx="0">
+            <a:schemeClr val="accent1"/>
+          </a:fillRef>
+          <a:effectRef idx="1">
+            <a:schemeClr val="accent1"/>
+          </a:effectRef>
+          <a:fontRef idx="minor">
+            <a:schemeClr val="tx1"/>
+          </a:fontRef>
+        </p:style>
+      </p:cxnSp>
+      <p:cxnSp>
+        <p:nvCxnSpPr>
+          <p:cNvPr id="9" name="Connector 9"/>
+          <p:cNvCxnSpPr/>
+          <p:nvPr/>
+        </p:nvCxnSpPr>
+        <p:spPr>
+          <a:xfrm flipV="1">
+            <a:off x="7163640" y="5251082"/>
+            <a:ext cx="1786962" cy="478815"/>
+          </a:xfrm>
+          <a:prstGeom prst="line">
+            <a:avLst/>
+          </a:prstGeom>
+          <a:ln w="25400">
+            <a:solidFill>
+              <a:srgbClr val="1B2A4A"/>
+            </a:solidFill>
+            <a:tailEnd type="triangle" w="med" len="med"/>
+          </a:ln>
+        </p:spPr>
+        <p:style>
+          <a:lnRef idx="2">
+            <a:schemeClr val="accent1"/>
+          </a:lnRef>
+          <a:fillRef idx="0">
+            <a:schemeClr val="accent1"/>
+          </a:fillRef>
+          <a:effectRef idx="1">
+            <a:schemeClr val="accent1"/>
+          </a:effectRef>
+          <a:fontRef idx="minor">
+            <a:schemeClr val="tx1"/>
+          </a:fontRef>
+        </p:style>
+      </p:cxnSp>
+      <p:sp>
+        <p:nvSpPr>
+          <p:cNvPr id="10" name="Arc 10"/>
+          <p:cNvSpPr/>
+          <p:nvPr/>
+        </p:nvSpPr>
+        <p:spPr>
+          <a:xfrm>
+            <a:off x="6543640" y="5109897"/>
+            <a:ext cx="1240000" cy="1240000"/>
+          </a:xfrm>
+          <a:prstGeom prst="arc">
+            <a:avLst>
+              <a:gd name="adj1" fmla="val 18600000"/>
+              <a:gd name="adj2" fmla="val 20700000"/>
+            </a:avLst>
+          </a:prstGeom>
+          <a:ln w="19050">
+            <a:solidFill>
+              <a:srgbClr val="3B5BDB"/>
+            </a:solidFill>
+          </a:ln>
+          <a:effectLst/>
+        </p:spPr>
+        <p:style>
+          <a:lnRef idx="2">
+            <a:schemeClr val="accent1"/>
+          </a:lnRef>
+          <a:fillRef idx="0">
+            <a:schemeClr val="accent1"/>
+          </a:fillRef>
+          <a:effectRef idx="1">
+            <a:schemeClr val="accent1"/>
+          </a:effectRef>
+          <a:fontRef idx="minor">
+            <a:schemeClr val="tx1"/>
+          </a:fontRef>
+        </p:style>
+        <p:txBody>
+          <a:bodyPr rtlCol="0" anchor="ctr"/>
+          <a:lstStyle/>
+          <a:p>
+            <a:pPr algn="ctr"/>
+          </a:p>
+        </p:txBody>
+      </p:sp>
+      <p:sp>
+        <p:nvSpPr>
+          <p:cNvPr id="11" name="TextBox 11"/>
+          <p:cNvSpPr txBox="1"/>
+          <p:nvPr/>
+        </p:nvSpPr>
+        <p:spPr>
+          <a:xfrm>
+            <a:off x="7688353" y="5150058"/>
+            <a:ext cx="300000" cy="300000"/>
+          </a:xfrm>
+          <a:prstGeom prst="rect">
+            <a:avLst/>
+          </a:prstGeom>
+          <a:noFill/>
+        </p:spPr>
+        <p:txBody>
+          <a:bodyPr wrap="square" lIns="0" rIns="0" tIns="0" bIns="0" anchor="ctr">
+            <a:spAutoFit/>
+          </a:bodyPr>
+          <a:lstStyle/>
+          <a:p>
+            <a:pPr algn="ctr"/>
+            <a:r>
+              <a:rPr sz="1400" b="1" i="0">
+                <a:solidFill>
+                  <a:srgbClr val="3B5BDB"/>
+                </a:solidFill>
+                <a:latin typeface="Calibri"/>
+              </a:rPr>
+              <a:t>θ</a:t>
+            </a:r>
+          </a:p>
+        </p:txBody>
+      </p:sp>
+      <p:sp>
+        <p:nvSpPr>
+          <p:cNvPr id="12" name="Oval 12"/>
+          <p:cNvSpPr/>
+          <p:nvPr/>
+        </p:nvSpPr>
+        <p:spPr>
+          <a:xfrm>
+            <a:off x="7123640" y="5689897"/>
+            <a:ext cx="80000" cy="80000"/>
+          </a:xfrm>
+          <a:prstGeom prst="ellipse">
+            <a:avLst/>
+          </a:prstGeom>
+          <a:solidFill>
+            <a:srgbClr val="1B2A4A"/>
+          </a:solidFill>
+          <a:ln>
+            <a:noFill/>
+          </a:ln>
+          <a:effectLst/>
+        </p:spPr>
+        <p:style>
+          <a:lnRef idx="1">
+            <a:schemeClr val="accent1"/>
+          </a:lnRef>
+          <a:fillRef idx="3">
+            <a:schemeClr val="accent1"/>
+          </a:fillRef>
+          <a:effectRef idx="2">
+            <a:schemeClr val="accent1"/>
+          </a:effectRef>
+          <a:fontRef idx="minor">
+            <a:schemeClr val="lt1"/>
+          </a:fontRef>
+        </p:style>
+        <p:txBody>
+          <a:bodyPr rtlCol="0" anchor="ctr"/>
+          <a:lstStyle/>
+          <a:p>
+            <a:pPr algn="ctr"/>
+          </a:p>
+        </p:txBody>
+      </p:sp>
+      <p:sp>
+        <p:nvSpPr>
+          <p:cNvPr id="13" name="TextBox 13"/>
+          <p:cNvSpPr txBox="1"/>
+          <p:nvPr/>
+        </p:nvSpPr>
+        <p:spPr>
+          <a:xfrm>
+            <a:off x="8392797" y="3972715"/>
+            <a:ext cx="300000" cy="300000"/>
+          </a:xfrm>
+          <a:prstGeom prst="rect">
+            <a:avLst/>
+          </a:prstGeom>
+          <a:noFill/>
+        </p:spPr>
+        <p:txBody>
+          <a:bodyPr wrap="square" lIns="0" rIns="0" tIns="0" bIns="0">
+            <a:spAutoFit/>
+          </a:bodyPr>
+          <a:lstStyle/>
+          <a:p>
+            <a:pPr algn="ctr"/>
+            <a:r>
+              <a:rPr sz="1500" b="1" i="0">
+                <a:solidFill>
+                  <a:srgbClr val="1B2A4A"/>
+                </a:solidFill>
+                <a:latin typeface="Calibri"/>
+              </a:rPr>
+              <a:t>A</a:t>
+            </a:r>
+          </a:p>
+        </p:txBody>
+      </p:sp>
+      <p:sp>
+        <p:nvSpPr>
+          <p:cNvPr id="14" name="TextBox 14"/>
+          <p:cNvSpPr txBox="1"/>
+          <p:nvPr/>
+        </p:nvSpPr>
+        <p:spPr>
+          <a:xfrm>
+            <a:off x="9010602" y="5111082"/>
+            <a:ext cx="300000" cy="300000"/>
+          </a:xfrm>
+          <a:prstGeom prst="rect">
+            <a:avLst/>
+          </a:prstGeom>
+          <a:noFill/>
+        </p:spPr>
+        <p:txBody>
+          <a:bodyPr wrap="square" lIns="0" rIns="0" tIns="0" bIns="0">
+            <a:spAutoFit/>
+          </a:bodyPr>
+          <a:lstStyle/>
+          <a:p>
+            <a:pPr algn="ctr"/>
+            <a:r>
+              <a:rPr sz="1500" b="1" i="0">
+                <a:solidFill>
+                  <a:srgbClr val="1B2A4A"/>
+                </a:solidFill>
+                <a:latin typeface="Calibri"/>
+              </a:rPr>
+              <a:t>B</a:t>
+            </a:r>
+          </a:p>
+        </p:txBody>
+      </p:sp>
+      <p:sp>
+        <p:nvSpPr>
+          <p:cNvPr id="15" name="TextBox 15"/>
+          <p:cNvSpPr txBox="1"/>
+          <p:nvPr/>
+        </p:nvSpPr>
+        <p:spPr>
+          <a:xfrm>
+            <a:off x="640080" y="6400800"/>
+            <a:ext cx="5486400" cy="320040"/>
+          </a:xfrm>
+          <a:prstGeom prst="rect">
+            <a:avLst/>
+          </a:prstGeom>
+          <a:noFill/>
+        </p:spPr>
+        <p:txBody>
+          <a:bodyPr wrap="square" lIns="0" rIns="0" tIns="0" bIns="0">
+            <a:spAutoFit/>
+          </a:bodyPr>
+          <a:lstStyle/>
+          <a:p>
+            <a:pPr algn="l"/>
+            <a:r>
+              <a:rPr sz="1000" b="0" i="0">
+                <a:solidFill>
+                  <a:srgbClr val="868E96"/>
+                </a:solidFill>
+                <a:latin typeface="Calibri"/>
+              </a:rPr>
+              <a:t>Laboratório de Estresse Semântico</a:t>
+            </a:r>
+          </a:p>
+        </p:txBody>
+      </p:sp>
+      <p:sp>
+        <p:nvSpPr>
+          <p:cNvPr id="16" name="TextBox 16"/>
+          <p:cNvSpPr txBox="1"/>
+          <p:nvPr/>
+        </p:nvSpPr>
+        <p:spPr>
+          <a:xfrm>
+            <a:off x="10637215" y="6400800"/>
+            <a:ext cx="914400" cy="320040"/>
+          </a:xfrm>
+          <a:prstGeom prst="rect">
+            <a:avLst/>
+          </a:prstGeom>
+          <a:noFill/>
+        </p:spPr>
+        <p:txBody>
+          <a:bodyPr wrap="square" lIns="0" rIns="0" tIns="0" bIns="0">
+            <a:spAutoFit/>
+          </a:bodyPr>
+          <a:lstStyle/>
+          <a:p>
+            <a:pPr algn="r"/>
+            <a:r>
+              <a:rPr sz="1000" b="0" i="0">
+                <a:solidFill>
+                  <a:srgbClr val="868E96"/>
+                </a:solidFill>
+                <a:latin typeface="Calibri"/>
+              </a:rPr>
+              <a:t>6</a:t>
             </a:r>
           </a:p>
         </p:txBody>

</xml_diff>

<commit_message>
Add text-length and multiple-regression confound checks, and rewrite README/pptx to narrate the full investigation arc.
Tests whether the size difference between texto_original and texto_simplificado explains the similarity drop, and whether it's confounded with context-dependency. The proportional expansion ratio correlates with similarity (r≈-0.43 to -0.47, p<0.05) but is not itself confounded with context-dependency (Mann-Whitney p≈0.60); a multiple regression shows both factors stay mostly significant when controlled for each other (R² 0.35-0.42). README and presentation updated to walk through hypothesis -> control baseline -> context confound -> dataset expansion -> size test -> two-factor conclusion, plus a closing note on chunk self-containedness as a follow-up question.

Co-Authored-By: Claude Sonnet 5 <noreply@anthropic.com>
Claude-Session: https://claude.ai/code/session_015ow45GH68uzExEbx6eFYei
</commit_message>
<xml_diff>
--- a/apresentacao/laboratorio_estresse_semantico.pptx
+++ b/apresentacao/laboratorio_estresse_semantico.pptx
@@ -16,6 +16,7 @@
     <p:sldId id="261" r:id="rId12"/>
     <p:sldId id="266" r:id="rId17"/>
     <p:sldId id="267" r:id="rId18"/>
+    <p:sldId id="268" r:id="rId19"/>
     <p:sldId id="262" r:id="rId13"/>
   </p:sldIdLst>
   <p:sldSz cx="12191695" cy="6858000" type="screen4x3"/>
@@ -5734,6 +5735,729 @@
 </p:sld>
 </file>
 
+<file path=ppt/slides/slide13.xml><?xml version="1.0" encoding="utf-8"?>
+<p:sld xmlns:a="http://schemas.openxmlformats.org/drawingml/2006/main" xmlns:p="http://schemas.openxmlformats.org/presentationml/2006/main" xmlns:r="http://schemas.openxmlformats.org/officeDocument/2006/relationships">
+  <p:cSld>
+    <p:bg>
+      <p:bgPr>
+        <a:solidFill>
+          <a:srgbClr val="FFFFFF"/>
+        </a:solidFill>
+        <a:effectLst/>
+      </p:bgPr>
+    </p:bg>
+    <p:spTree>
+      <p:nvGrpSpPr>
+        <p:cNvPr id="1" name=""/>
+        <p:cNvGrpSpPr/>
+        <p:nvPr/>
+      </p:nvGrpSpPr>
+      <p:grpSpPr/>
+      <p:sp>
+        <p:nvSpPr>
+          <p:cNvPr id="2" name="TextBox 23"/>
+          <p:cNvSpPr txBox="1"/>
+          <p:nvPr/>
+        </p:nvSpPr>
+        <p:spPr>
+          <a:xfrm>
+            <a:off x="640080" y="411480"/>
+            <a:ext cx="10911535" cy="320040"/>
+          </a:xfrm>
+          <a:prstGeom prst="rect">
+            <a:avLst/>
+          </a:prstGeom>
+          <a:noFill/>
+        </p:spPr>
+        <p:txBody>
+          <a:bodyPr wrap="square" lIns="0" rIns="0" tIns="0" bIns="0">
+            <a:spAutoFit/>
+          </a:bodyPr>
+          <a:lstStyle/>
+          <a:p>
+            <a:pPr algn="l"/>
+            <a:r>
+              <a:rPr sz="1200" b="1" i="0">
+                <a:solidFill>
+                  <a:srgbClr val="3B5BDB"/>
+                </a:solidFill>
+                <a:latin typeface="Calibri"/>
+              </a:rPr>
+              <a:t>SÍNTESE FINAL</a:t>
+            </a:r>
+          </a:p>
+        </p:txBody>
+      </p:sp>
+      <p:sp>
+        <p:nvSpPr>
+          <p:cNvPr id="3" name="TextBox 24"/>
+          <p:cNvSpPr txBox="1"/>
+          <p:nvPr/>
+        </p:nvSpPr>
+        <p:spPr>
+          <a:xfrm>
+            <a:off x="640080" y="777240"/>
+            <a:ext cx="10911535" cy="731520"/>
+          </a:xfrm>
+          <a:prstGeom prst="rect">
+            <a:avLst/>
+          </a:prstGeom>
+          <a:noFill/>
+        </p:spPr>
+        <p:txBody>
+          <a:bodyPr wrap="square" lIns="0" rIns="0" tIns="0" bIns="0">
+            <a:spAutoFit/>
+          </a:bodyPr>
+          <a:lstStyle/>
+          <a:p>
+            <a:pPr algn="l"/>
+            <a:r>
+              <a:rPr sz="3000" b="1" i="0">
+                <a:solidFill>
+                  <a:srgbClr val="1B2A4A"/>
+                </a:solidFill>
+                <a:latin typeface="Calibri"/>
+              </a:rPr>
+              <a:t>Não é o fenômeno — são duas variáveis reais</a:t>
+            </a:r>
+          </a:p>
+        </p:txBody>
+      </p:sp>
+      <p:sp>
+        <p:nvSpPr>
+          <p:cNvPr id="4" name="Rounded Rectangle 4"/>
+          <p:cNvSpPr/>
+          <p:nvPr/>
+        </p:nvSpPr>
+        <p:spPr>
+          <a:xfrm>
+            <a:off x="640080" y="1600200"/>
+            <a:ext cx="5212080" cy="3246120"/>
+          </a:xfrm>
+          <a:prstGeom prst="roundRect">
+            <a:avLst>
+              <a:gd name="adj" fmla="val 6000"/>
+            </a:avLst>
+          </a:prstGeom>
+          <a:solidFill>
+            <a:srgbClr val="F6F7F9"/>
+          </a:solidFill>
+          <a:ln>
+            <a:noFill/>
+          </a:ln>
+          <a:effectLst/>
+        </p:spPr>
+        <p:style>
+          <a:lnRef idx="1">
+            <a:schemeClr val="accent1"/>
+          </a:lnRef>
+          <a:fillRef idx="3">
+            <a:schemeClr val="accent1"/>
+          </a:fillRef>
+          <a:effectRef idx="2">
+            <a:schemeClr val="accent1"/>
+          </a:effectRef>
+          <a:fontRef idx="minor">
+            <a:schemeClr val="lt1"/>
+          </a:fontRef>
+        </p:style>
+        <p:txBody>
+          <a:bodyPr rtlCol="0" anchor="ctr"/>
+          <a:lstStyle/>
+          <a:p>
+            <a:pPr algn="ctr"/>
+          </a:p>
+        </p:txBody>
+      </p:sp>
+      <p:sp>
+        <p:nvSpPr>
+          <p:cNvPr id="5" name="Rounded Rectangle 5"/>
+          <p:cNvSpPr/>
+          <p:nvPr/>
+        </p:nvSpPr>
+        <p:spPr>
+          <a:xfrm>
+            <a:off x="914400" y="1856232"/>
+            <a:ext cx="2822000" cy="365760"/>
+          </a:xfrm>
+          <a:prstGeom prst="roundRect">
+            <a:avLst>
+              <a:gd name="adj" fmla="val 50000"/>
+            </a:avLst>
+          </a:prstGeom>
+          <a:solidFill>
+            <a:srgbClr val="FDECE0"/>
+          </a:solidFill>
+          <a:ln>
+            <a:noFill/>
+          </a:ln>
+          <a:effectLst/>
+        </p:spPr>
+        <p:style>
+          <a:lnRef idx="1">
+            <a:schemeClr val="accent1"/>
+          </a:lnRef>
+          <a:fillRef idx="3">
+            <a:schemeClr val="accent1"/>
+          </a:fillRef>
+          <a:effectRef idx="2">
+            <a:schemeClr val="accent1"/>
+          </a:effectRef>
+          <a:fontRef idx="minor">
+            <a:schemeClr val="lt1"/>
+          </a:fontRef>
+        </p:style>
+        <p:txBody>
+          <a:bodyPr rtlCol="0" anchor="ctr" wrap="square" lIns="228600" rIns="228600"/>
+          <a:lstStyle/>
+          <a:p>
+            <a:pPr algn="ctr"/>
+            <a:r>
+              <a:rPr sz="1200" b="1" i="0">
+                <a:solidFill>
+                  <a:srgbClr val="E8590C"/>
+                </a:solidFill>
+                <a:latin typeface="Calibri"/>
+              </a:rPr>
+              <a:t>FATOR 1 — TAMANHO</a:t>
+            </a:r>
+          </a:p>
+        </p:txBody>
+      </p:sp>
+      <p:sp>
+        <p:nvSpPr>
+          <p:cNvPr id="6" name="TextBox 6"/>
+          <p:cNvSpPr txBox="1"/>
+          <p:nvPr/>
+        </p:nvSpPr>
+        <p:spPr>
+          <a:xfrm>
+            <a:off x="914400" y="2331720"/>
+            <a:ext cx="4663440" cy="365760"/>
+          </a:xfrm>
+          <a:prstGeom prst="rect">
+            <a:avLst/>
+          </a:prstGeom>
+          <a:noFill/>
+        </p:spPr>
+        <p:txBody>
+          <a:bodyPr wrap="square" lIns="0" rIns="0" tIns="0" bIns="0">
+            <a:spAutoFit/>
+          </a:bodyPr>
+          <a:lstStyle/>
+          <a:p>
+            <a:pPr algn="l"/>
+            <a:r>
+              <a:rPr sz="1450" b="1" i="0">
+                <a:solidFill>
+                  <a:srgbClr val="1B2A4A"/>
+                </a:solidFill>
+                <a:latin typeface="Calibri"/>
+              </a:rPr>
+              <a:t>Razão de expansão do texto</a:t>
+            </a:r>
+          </a:p>
+        </p:txBody>
+      </p:sp>
+      <p:sp>
+        <p:nvSpPr>
+          <p:cNvPr id="7" name="TextBox 7"/>
+          <p:cNvSpPr txBox="1"/>
+          <p:nvPr/>
+        </p:nvSpPr>
+        <p:spPr>
+          <a:xfrm>
+            <a:off x="914400" y="2770632"/>
+            <a:ext cx="4663440" cy="777240"/>
+          </a:xfrm>
+          <a:prstGeom prst="rect">
+            <a:avLst/>
+          </a:prstGeom>
+          <a:noFill/>
+        </p:spPr>
+        <p:txBody>
+          <a:bodyPr wrap="square" lIns="0" rIns="0" tIns="0" bIns="0">
+            <a:spAutoFit/>
+          </a:bodyPr>
+          <a:lstStyle/>
+          <a:p>
+            <a:pPr algn="l">
+              <a:lnSpc>
+                <a:spcPct val="110000"/>
+              </a:lnSpc>
+            </a:pPr>
+            <a:r>
+              <a:rPr sz="1200" b="0" i="1">
+                <a:solidFill>
+                  <a:srgbClr val="495057"/>
+                </a:solidFill>
+                <a:latin typeface="Calibri"/>
+              </a:rPr>
+              <a:t>Quanto mais a versão simplificada precisa se alongar, proporcionalmente, para compensar a figura retórica removida</a:t>
+            </a:r>
+          </a:p>
+        </p:txBody>
+      </p:sp>
+      <p:sp>
+        <p:nvSpPr>
+          <p:cNvPr id="8" name="TextBox 8"/>
+          <p:cNvSpPr txBox="1"/>
+          <p:nvPr/>
+        </p:nvSpPr>
+        <p:spPr>
+          <a:xfrm>
+            <a:off x="914400" y="3593592"/>
+            <a:ext cx="4663440" cy="548640"/>
+          </a:xfrm>
+          <a:prstGeom prst="rect">
+            <a:avLst/>
+          </a:prstGeom>
+          <a:noFill/>
+        </p:spPr>
+        <p:txBody>
+          <a:bodyPr wrap="square" lIns="0" rIns="0" tIns="0" bIns="0">
+            <a:spAutoFit/>
+          </a:bodyPr>
+          <a:lstStyle/>
+          <a:p>
+            <a:pPr algn="l">
+              <a:lnSpc>
+                <a:spcPct val="110000"/>
+              </a:lnSpc>
+            </a:pPr>
+            <a:r>
+              <a:rPr sz="1200" b="0" i="0">
+                <a:solidFill>
+                  <a:srgbClr val="495057"/>
+                </a:solidFill>
+                <a:latin typeface="Calibri"/>
+              </a:rPr>
+              <a:t>→ correlação negativa moderada, nos três modelos, entre razão de tamanho e similaridade</a:t>
+            </a:r>
+          </a:p>
+        </p:txBody>
+      </p:sp>
+      <p:sp>
+        <p:nvSpPr>
+          <p:cNvPr id="11" name="TextBox 11"/>
+          <p:cNvSpPr txBox="1"/>
+          <p:nvPr/>
+        </p:nvSpPr>
+        <p:spPr>
+          <a:xfrm>
+            <a:off x="914400" y="4297680"/>
+            <a:ext cx="4663440" cy="365760"/>
+          </a:xfrm>
+          <a:prstGeom prst="rect">
+            <a:avLst/>
+          </a:prstGeom>
+          <a:noFill/>
+        </p:spPr>
+        <p:txBody>
+          <a:bodyPr wrap="square" lIns="0" rIns="0" tIns="0" bIns="0">
+            <a:spAutoFit/>
+          </a:bodyPr>
+          <a:lstStyle/>
+          <a:p>
+            <a:pPr algn="l"/>
+            <a:r>
+              <a:rPr sz="1250" b="1" i="0">
+                <a:solidFill>
+                  <a:srgbClr val="E8590C"/>
+                </a:solidFill>
+                <a:latin typeface="Calibri"/>
+              </a:rPr>
+              <a:t>r ≈ -0,43 a -0,47  ·  p &lt; 0,05 (3 modelos)</a:t>
+            </a:r>
+          </a:p>
+        </p:txBody>
+      </p:sp>
+      <p:sp>
+        <p:nvSpPr>
+          <p:cNvPr id="12" name="Rounded Rectangle 12"/>
+          <p:cNvSpPr/>
+          <p:nvPr/>
+        </p:nvSpPr>
+        <p:spPr>
+          <a:xfrm>
+            <a:off x="6309360" y="1600200"/>
+            <a:ext cx="5212080" cy="3246120"/>
+          </a:xfrm>
+          <a:prstGeom prst="roundRect">
+            <a:avLst>
+              <a:gd name="adj" fmla="val 6000"/>
+            </a:avLst>
+          </a:prstGeom>
+          <a:solidFill>
+            <a:srgbClr val="F6F7F9"/>
+          </a:solidFill>
+          <a:ln>
+            <a:noFill/>
+          </a:ln>
+          <a:effectLst/>
+        </p:spPr>
+        <p:style>
+          <a:lnRef idx="1">
+            <a:schemeClr val="accent1"/>
+          </a:lnRef>
+          <a:fillRef idx="3">
+            <a:schemeClr val="accent1"/>
+          </a:fillRef>
+          <a:effectRef idx="2">
+            <a:schemeClr val="accent1"/>
+          </a:effectRef>
+          <a:fontRef idx="minor">
+            <a:schemeClr val="lt1"/>
+          </a:fontRef>
+        </p:style>
+        <p:txBody>
+          <a:bodyPr rtlCol="0" anchor="ctr"/>
+          <a:lstStyle/>
+          <a:p>
+            <a:pPr algn="ctr"/>
+          </a:p>
+        </p:txBody>
+      </p:sp>
+      <p:sp>
+        <p:nvSpPr>
+          <p:cNvPr id="13" name="Rounded Rectangle 13"/>
+          <p:cNvSpPr/>
+          <p:nvPr/>
+        </p:nvSpPr>
+        <p:spPr>
+          <a:xfrm>
+            <a:off x="6583680" y="1856232"/>
+            <a:ext cx="2822000" cy="365760"/>
+          </a:xfrm>
+          <a:prstGeom prst="roundRect">
+            <a:avLst>
+              <a:gd name="adj" fmla="val 50000"/>
+            </a:avLst>
+          </a:prstGeom>
+          <a:solidFill>
+            <a:srgbClr val="FDECE0"/>
+          </a:solidFill>
+          <a:ln>
+            <a:noFill/>
+          </a:ln>
+          <a:effectLst/>
+        </p:spPr>
+        <p:style>
+          <a:lnRef idx="1">
+            <a:schemeClr val="accent1"/>
+          </a:lnRef>
+          <a:fillRef idx="3">
+            <a:schemeClr val="accent1"/>
+          </a:fillRef>
+          <a:effectRef idx="2">
+            <a:schemeClr val="accent1"/>
+          </a:effectRef>
+          <a:fontRef idx="minor">
+            <a:schemeClr val="lt1"/>
+          </a:fontRef>
+        </p:style>
+        <p:txBody>
+          <a:bodyPr rtlCol="0" anchor="ctr" wrap="square" lIns="228600" rIns="228600"/>
+          <a:lstStyle/>
+          <a:p>
+            <a:pPr algn="ctr"/>
+            <a:r>
+              <a:rPr sz="1200" b="1" i="0">
+                <a:solidFill>
+                  <a:srgbClr val="E8590C"/>
+                </a:solidFill>
+                <a:latin typeface="Calibri"/>
+              </a:rPr>
+              <a:t>FATOR 2 — CONTEXTO</a:t>
+            </a:r>
+          </a:p>
+        </p:txBody>
+      </p:sp>
+      <p:sp>
+        <p:nvSpPr>
+          <p:cNvPr id="14" name="TextBox 14"/>
+          <p:cNvSpPr txBox="1"/>
+          <p:nvPr/>
+        </p:nvSpPr>
+        <p:spPr>
+          <a:xfrm>
+            <a:off x="6583680" y="2331720"/>
+            <a:ext cx="4663440" cy="365760"/>
+          </a:xfrm>
+          <a:prstGeom prst="rect">
+            <a:avLst/>
+          </a:prstGeom>
+          <a:noFill/>
+        </p:spPr>
+        <p:txBody>
+          <a:bodyPr wrap="square" lIns="0" rIns="0" tIns="0" bIns="0">
+            <a:spAutoFit/>
+          </a:bodyPr>
+          <a:lstStyle/>
+          <a:p>
+            <a:pPr algn="l"/>
+            <a:r>
+              <a:rPr sz="1450" b="1" i="0">
+                <a:solidFill>
+                  <a:srgbClr val="1B2A4A"/>
+                </a:solidFill>
+                <a:latin typeface="Calibri"/>
+              </a:rPr>
+              <a:t>Dependência de contexto ausente</a:t>
+            </a:r>
+          </a:p>
+        </p:txBody>
+      </p:sp>
+      <p:sp>
+        <p:nvSpPr>
+          <p:cNvPr id="15" name="TextBox 15"/>
+          <p:cNvSpPr txBox="1"/>
+          <p:nvPr/>
+        </p:nvSpPr>
+        <p:spPr>
+          <a:xfrm>
+            <a:off x="6583680" y="2770632"/>
+            <a:ext cx="4663440" cy="777240"/>
+          </a:xfrm>
+          <a:prstGeom prst="rect">
+            <a:avLst/>
+          </a:prstGeom>
+          <a:noFill/>
+        </p:spPr>
+        <p:txBody>
+          <a:bodyPr wrap="square" lIns="0" rIns="0" tIns="0" bIns="0">
+            <a:spAutoFit/>
+          </a:bodyPr>
+          <a:lstStyle/>
+          <a:p>
+            <a:pPr algn="l">
+              <a:lnSpc>
+                <a:spcPct val="110000"/>
+              </a:lnSpc>
+            </a:pPr>
+            <a:r>
+              <a:rPr sz="1200" b="0" i="1">
+                <a:solidFill>
+                  <a:srgbClr val="495057"/>
+                </a:solidFill>
+                <a:latin typeface="Calibri"/>
+              </a:rPr>
+              <a:t>Controlando estatisticamente pela razão de tamanho, numa regressão múltipla com os dois fatores juntos</a:t>
+            </a:r>
+          </a:p>
+        </p:txBody>
+      </p:sp>
+      <p:sp>
+        <p:nvSpPr>
+          <p:cNvPr id="16" name="TextBox 16"/>
+          <p:cNvSpPr txBox="1"/>
+          <p:nvPr/>
+        </p:nvSpPr>
+        <p:spPr>
+          <a:xfrm>
+            <a:off x="6583680" y="3593592"/>
+            <a:ext cx="4663440" cy="548640"/>
+          </a:xfrm>
+          <a:prstGeom prst="rect">
+            <a:avLst/>
+          </a:prstGeom>
+          <a:noFill/>
+        </p:spPr>
+        <p:txBody>
+          <a:bodyPr wrap="square" lIns="0" rIns="0" tIns="0" bIns="0">
+            <a:spAutoFit/>
+          </a:bodyPr>
+          <a:lstStyle/>
+          <a:p>
+            <a:pPr algn="l">
+              <a:lnSpc>
+                <a:spcPct val="110000"/>
+              </a:lnSpc>
+            </a:pPr>
+            <a:r>
+              <a:rPr sz="1200" b="0" i="0">
+                <a:solidFill>
+                  <a:srgbClr val="495057"/>
+                </a:solidFill>
+                <a:latin typeface="Calibri"/>
+              </a:rPr>
+              <a:t>→ continua reduzindo a similaridade mesmo controlando pelo tamanho</a:t>
+            </a:r>
+          </a:p>
+        </p:txBody>
+      </p:sp>
+      <p:sp>
+        <p:nvSpPr>
+          <p:cNvPr id="19" name="TextBox 19"/>
+          <p:cNvSpPr txBox="1"/>
+          <p:nvPr/>
+        </p:nvSpPr>
+        <p:spPr>
+          <a:xfrm>
+            <a:off x="6583680" y="4297680"/>
+            <a:ext cx="4663440" cy="365760"/>
+          </a:xfrm>
+          <a:prstGeom prst="rect">
+            <a:avLst/>
+          </a:prstGeom>
+          <a:noFill/>
+        </p:spPr>
+        <p:txBody>
+          <a:bodyPr wrap="square" lIns="0" rIns="0" tIns="0" bIns="0">
+            <a:spAutoFit/>
+          </a:bodyPr>
+          <a:lstStyle/>
+          <a:p>
+            <a:pPr algn="l"/>
+            <a:r>
+              <a:rPr sz="1250" b="1" i="0">
+                <a:solidFill>
+                  <a:srgbClr val="E8590C"/>
+                </a:solidFill>
+                <a:latin typeface="Calibri"/>
+              </a:rPr>
+              <a:t>p ≈ 0,007 a 0,035  ·  R² 0,35–0,42</a:t>
+            </a:r>
+          </a:p>
+        </p:txBody>
+      </p:sp>
+      <p:sp>
+        <p:nvSpPr>
+          <p:cNvPr id="20" name="Rounded Rectangle 20"/>
+          <p:cNvSpPr/>
+          <p:nvPr/>
+        </p:nvSpPr>
+        <p:spPr>
+          <a:xfrm>
+            <a:off x="640080" y="5532120"/>
+            <a:ext cx="10911535" cy="777240"/>
+          </a:xfrm>
+          <a:prstGeom prst="roundRect">
+            <a:avLst>
+              <a:gd name="adj" fmla="val 10000"/>
+            </a:avLst>
+          </a:prstGeom>
+          <a:solidFill>
+            <a:srgbClr val="E7ECFC"/>
+          </a:solidFill>
+          <a:ln>
+            <a:noFill/>
+          </a:ln>
+          <a:effectLst/>
+        </p:spPr>
+        <p:style>
+          <a:lnRef idx="1">
+            <a:schemeClr val="accent1"/>
+          </a:lnRef>
+          <a:fillRef idx="3">
+            <a:schemeClr val="accent1"/>
+          </a:fillRef>
+          <a:effectRef idx="2">
+            <a:schemeClr val="accent1"/>
+          </a:effectRef>
+          <a:fontRef idx="minor">
+            <a:schemeClr val="lt1"/>
+          </a:fontRef>
+        </p:style>
+        <p:txBody>
+          <a:bodyPr rtlCol="0" anchor="ctr" wrap="square" lIns="320040" rIns="320040"/>
+          <a:lstStyle/>
+          <a:p>
+            <a:pPr algn="l">
+              <a:lnSpc>
+                <a:spcPct val="115000"/>
+              </a:lnSpc>
+            </a:pPr>
+            <a:r>
+              <a:rPr sz="1300" b="0" i="1">
+                <a:solidFill>
+                  <a:srgbClr val="1B2A4A"/>
+                </a:solidFill>
+                <a:latin typeface="Calibri"/>
+              </a:rPr>
+              <a:t>Numa regressão múltipla com os dois fatores juntos, ambos seguem estatisticamente significativos controlando um pelo outro — evidência de que são majoritariamente independentes, não um mascarando o outro. Com n=25 e 2 preditores (22 graus de liberdade residuais), é indicativo, não conclusivo.</a:t>
+            </a:r>
+          </a:p>
+        </p:txBody>
+      </p:sp>
+      <p:sp>
+        <p:nvSpPr>
+          <p:cNvPr id="21" name="TextBox 21"/>
+          <p:cNvSpPr txBox="1"/>
+          <p:nvPr/>
+        </p:nvSpPr>
+        <p:spPr>
+          <a:xfrm>
+            <a:off x="640080" y="6400800"/>
+            <a:ext cx="5486400" cy="320040"/>
+          </a:xfrm>
+          <a:prstGeom prst="rect">
+            <a:avLst/>
+          </a:prstGeom>
+          <a:noFill/>
+        </p:spPr>
+        <p:txBody>
+          <a:bodyPr wrap="square" lIns="0" rIns="0" tIns="0" bIns="0">
+            <a:spAutoFit/>
+          </a:bodyPr>
+          <a:lstStyle/>
+          <a:p>
+            <a:pPr algn="l"/>
+            <a:r>
+              <a:rPr sz="1000" b="0" i="0">
+                <a:solidFill>
+                  <a:srgbClr val="868E96"/>
+                </a:solidFill>
+                <a:latin typeface="Calibri"/>
+              </a:rPr>
+              <a:t>Laboratório de Estresse Semântico</a:t>
+            </a:r>
+          </a:p>
+        </p:txBody>
+      </p:sp>
+      <p:sp>
+        <p:nvSpPr>
+          <p:cNvPr id="22" name="TextBox 22"/>
+          <p:cNvSpPr txBox="1"/>
+          <p:nvPr/>
+        </p:nvSpPr>
+        <p:spPr>
+          <a:xfrm>
+            <a:off x="10637215" y="6400800"/>
+            <a:ext cx="914400" cy="320040"/>
+          </a:xfrm>
+          <a:prstGeom prst="rect">
+            <a:avLst/>
+          </a:prstGeom>
+          <a:noFill/>
+        </p:spPr>
+        <p:txBody>
+          <a:bodyPr wrap="square" lIns="0" rIns="0" tIns="0" bIns="0">
+            <a:spAutoFit/>
+          </a:bodyPr>
+          <a:lstStyle/>
+          <a:p>
+            <a:pPr algn="r"/>
+            <a:r>
+              <a:rPr sz="1000" b="0" i="0">
+                <a:solidFill>
+                  <a:srgbClr val="868E96"/>
+                </a:solidFill>
+                <a:latin typeface="Calibri"/>
+              </a:rPr>
+              <a:t>12</a:t>
+            </a:r>
+          </a:p>
+        </p:txBody>
+      </p:sp>
+    </p:spTree>
+  </p:cSld>
+  <p:clrMapOvr>
+    <a:masterClrMapping/>
+  </p:clrMapOvr>
+</p:sld>
+</file>
+
 <file path=ppt/slides/slide2.xml><?xml version="1.0" encoding="utf-8"?>
 <p:sld xmlns:a="http://schemas.openxmlformats.org/drawingml/2006/main" xmlns:p="http://schemas.openxmlformats.org/presentationml/2006/main" xmlns:r="http://schemas.openxmlformats.org/officeDocument/2006/relationships">
   <p:cSld>
@@ -9315,7 +10039,7 @@
                 </a:solidFill>
                 <a:latin typeface="Calibri"/>
               </a:rPr>
-              <a:t>Achado preliminar: os modelos de embedding parecem depender mais da forma da frase do que seria ideal.</a:t>
+              <a:t>Leitura preliminar, baseada em n=1 por fenômeno: como os próximos slides mostram, essa hierarquia por categoria retórica não se sustentou com mais dados — o que de fato explica a queda é o contexto ausente e o tamanho da reescrita, não a figura em si.</a:t>
             </a:r>
           </a:p>
         </p:txBody>
@@ -9664,7 +10388,7 @@
             <a:avLst/>
           </a:prstGeom>
           <a:solidFill>
-            <a:srgbClr val="3B5BDB"/>
+            <a:srgbClr val="0CA678"/>
           </a:solidFill>
           <a:ln>
             <a:noFill/>
@@ -9732,7 +10456,7 @@
                 </a:solidFill>
                 <a:latin typeface="Calibri"/>
               </a:rPr>
-              <a:t>Testar correlação com o tamanho do texto</a:t>
+              <a:t>Testar correlação com o tamanho do texto (concluído)</a:t>
             </a:r>
           </a:p>
         </p:txBody>
@@ -9771,7 +10495,7 @@
                 </a:solidFill>
                 <a:latin typeface="Calibri"/>
               </a:rPr>
-              <a:t>Verificar se a extensão do fragmento, por si só, explica parte da deriva observada.</a:t>
+              <a:t>A diferença absoluta de caracteres não correlaciona com a similaridade, mas a razão de expansão (simplificado / original) sim: r ≈ -0,43 a -0,47, p &lt; 0,05 nos três modelos (Seção 8.1).</a:t>
             </a:r>
           </a:p>
         </p:txBody>
@@ -9827,7 +10551,7 @@
             <a:avLst/>
           </a:prstGeom>
           <a:solidFill>
-            <a:srgbClr val="3B5BDB"/>
+            <a:srgbClr val="0CA678"/>
           </a:solidFill>
           <a:ln>
             <a:noFill/>
@@ -9895,7 +10619,7 @@
                 </a:solidFill>
                 <a:latin typeface="Calibri"/>
               </a:rPr>
-              <a:t>Análise estatística mais robusta</a:t>
+              <a:t>Regressão múltipla: dois fatores independentes (concluído)</a:t>
             </a:r>
           </a:p>
         </p:txBody>
@@ -9934,7 +10658,7 @@
                 </a:solidFill>
                 <a:latin typeface="Calibri"/>
               </a:rPr>
-              <a:t>Com n=25, Paradoxo, Antítese, Hipérbato e Zeugma já têm múltiplas observações (Seção 8) — e a hierarquia original não se sustentou. Falta balancear autocontido/dependente de contexto dentro de cada fenômeno para separar os dois efeitos.</a:t>
+              <a:t>Controlando dependência de contexto e razão de tamanho um pelo outro, os dois seguem significativos (R² 0,35–0,42) — evidência de que são majoritariamente independentes, não uma hierarquia de fenômenos retóricos. Com n=25 e 2 preditores (22 gl residuais), falta um dataset maior e balanceado (categoria × contexto × tamanho) para separar os efeitos com mais poder estatístico.</a:t>
             </a:r>
           </a:p>
         </p:txBody>
@@ -10004,7 +10728,7 @@
                 </a:solidFill>
                 <a:latin typeface="Calibri"/>
               </a:rPr>
-              <a:t>12</a:t>
+              <a:t>13</a:t>
             </a:r>
           </a:p>
         </p:txBody>

</xml_diff>

<commit_message>
Add a RAG-implications slide to the presentation, a README for the apresentacao folder, and clarifying notes to the notebook.
The new slide connects the context-dependency finding to document-QA/RAG pipelines: a chunk cut without its surrounding context gets a degraded embedding, which can keep the LLM from ever seeing the right passage. The apresentacao README clarifies the deck's scope (Portuguese, professor presentation only). The notebook notes explain propositional content vs. surface form in plain terms and flag that the original n=12 "Paradoxo is worst" hierarchy didn't survive the n=25 expansion.

Co-Authored-By: Claude Sonnet 5 <noreply@anthropic.com>
Claude-Session: https://claude.ai/code/session_012Hs9BqEDKQkYS6UQd5WYGj
</commit_message>
<xml_diff>
--- a/apresentacao/laboratorio_estresse_semantico.pptx
+++ b/apresentacao/laboratorio_estresse_semantico.pptx
@@ -17,6 +17,7 @@
     <p:sldId id="266" r:id="rId17"/>
     <p:sldId id="267" r:id="rId18"/>
     <p:sldId id="268" r:id="rId19"/>
+    <p:sldId id="269" r:id="rId20"/>
     <p:sldId id="262" r:id="rId13"/>
   </p:sldIdLst>
   <p:sldSz cx="12191695" cy="6858000" type="screen4x3"/>
@@ -6458,6 +6459,729 @@
 </p:sld>
 </file>
 
+<file path=ppt/slides/slide14.xml><?xml version="1.0" encoding="utf-8"?>
+<p:sld xmlns:a="http://schemas.openxmlformats.org/drawingml/2006/main" xmlns:p="http://schemas.openxmlformats.org/presentationml/2006/main" xmlns:r="http://schemas.openxmlformats.org/officeDocument/2006/relationships">
+  <p:cSld>
+    <p:bg>
+      <p:bgPr>
+        <a:solidFill>
+          <a:srgbClr val="FFFFFF"/>
+        </a:solidFill>
+        <a:effectLst/>
+      </p:bgPr>
+    </p:bg>
+    <p:spTree>
+      <p:nvGrpSpPr>
+        <p:cNvPr id="1" name=""/>
+        <p:cNvGrpSpPr/>
+        <p:nvPr/>
+      </p:nvGrpSpPr>
+      <p:grpSpPr/>
+      <p:sp>
+        <p:nvSpPr>
+          <p:cNvPr id="2" name="TextBox 23"/>
+          <p:cNvSpPr txBox="1"/>
+          <p:nvPr/>
+        </p:nvSpPr>
+        <p:spPr>
+          <a:xfrm>
+            <a:off x="640080" y="411480"/>
+            <a:ext cx="10911535" cy="320040"/>
+          </a:xfrm>
+          <a:prstGeom prst="rect">
+            <a:avLst/>
+          </a:prstGeom>
+          <a:noFill/>
+        </p:spPr>
+        <p:txBody>
+          <a:bodyPr wrap="square" lIns="0" rIns="0" tIns="0" bIns="0">
+            <a:spAutoFit/>
+          </a:bodyPr>
+          <a:lstStyle/>
+          <a:p>
+            <a:pPr algn="l"/>
+            <a:r>
+              <a:rPr sz="1200" b="1" i="0">
+                <a:solidFill>
+                  <a:srgbClr val="3B5BDB"/>
+                </a:solidFill>
+                <a:latin typeface="Calibri"/>
+              </a:rPr>
+              <a:t>IMPLICAÇÃO PRÁTICA</a:t>
+            </a:r>
+          </a:p>
+        </p:txBody>
+      </p:sp>
+      <p:sp>
+        <p:nvSpPr>
+          <p:cNvPr id="3" name="TextBox 24"/>
+          <p:cNvSpPr txBox="1"/>
+          <p:nvPr/>
+        </p:nvSpPr>
+        <p:spPr>
+          <a:xfrm>
+            <a:off x="640080" y="777240"/>
+            <a:ext cx="10911535" cy="731520"/>
+          </a:xfrm>
+          <a:prstGeom prst="rect">
+            <a:avLst/>
+          </a:prstGeom>
+          <a:noFill/>
+        </p:spPr>
+        <p:txBody>
+          <a:bodyPr wrap="square" lIns="0" rIns="0" tIns="0" bIns="0">
+            <a:spAutoFit/>
+          </a:bodyPr>
+          <a:lstStyle/>
+          <a:p>
+            <a:pPr algn="l"/>
+            <a:r>
+              <a:rPr sz="3000" b="1" i="0">
+                <a:solidFill>
+                  <a:srgbClr val="1B2A4A"/>
+                </a:solidFill>
+                <a:latin typeface="Calibri"/>
+              </a:rPr>
+              <a:t>O que isso sugere para IA sobre documentos (RAG)</a:t>
+            </a:r>
+          </a:p>
+        </p:txBody>
+      </p:sp>
+      <p:sp>
+        <p:nvSpPr>
+          <p:cNvPr id="4" name="Rounded Rectangle 4"/>
+          <p:cNvSpPr/>
+          <p:nvPr/>
+        </p:nvSpPr>
+        <p:spPr>
+          <a:xfrm>
+            <a:off x="640080" y="1600200"/>
+            <a:ext cx="5212080" cy="3246120"/>
+          </a:xfrm>
+          <a:prstGeom prst="roundRect">
+            <a:avLst>
+              <a:gd name="adj" fmla="val 6000"/>
+            </a:avLst>
+          </a:prstGeom>
+          <a:solidFill>
+            <a:srgbClr val="F6F7F9"/>
+          </a:solidFill>
+          <a:ln>
+            <a:noFill/>
+          </a:ln>
+          <a:effectLst/>
+        </p:spPr>
+        <p:style>
+          <a:lnRef idx="1">
+            <a:schemeClr val="accent1"/>
+          </a:lnRef>
+          <a:fillRef idx="3">
+            <a:schemeClr val="accent1"/>
+          </a:fillRef>
+          <a:effectRef idx="2">
+            <a:schemeClr val="accent1"/>
+          </a:effectRef>
+          <a:fontRef idx="minor">
+            <a:schemeClr val="lt1"/>
+          </a:fontRef>
+        </p:style>
+        <p:txBody>
+          <a:bodyPr rtlCol="0" anchor="ctr"/>
+          <a:lstStyle/>
+          <a:p>
+            <a:pPr algn="ctr"/>
+          </a:p>
+        </p:txBody>
+      </p:sp>
+      <p:sp>
+        <p:nvSpPr>
+          <p:cNvPr id="5" name="Rounded Rectangle 5"/>
+          <p:cNvSpPr/>
+          <p:nvPr/>
+        </p:nvSpPr>
+        <p:spPr>
+          <a:xfrm>
+            <a:off x="914400" y="1856232"/>
+            <a:ext cx="2822000" cy="365760"/>
+          </a:xfrm>
+          <a:prstGeom prst="roundRect">
+            <a:avLst>
+              <a:gd name="adj" fmla="val 50000"/>
+            </a:avLst>
+          </a:prstGeom>
+          <a:solidFill>
+            <a:srgbClr val="FDECE0"/>
+          </a:solidFill>
+          <a:ln>
+            <a:noFill/>
+          </a:ln>
+          <a:effectLst/>
+        </p:spPr>
+        <p:style>
+          <a:lnRef idx="1">
+            <a:schemeClr val="accent1"/>
+          </a:lnRef>
+          <a:fillRef idx="3">
+            <a:schemeClr val="accent1"/>
+          </a:fillRef>
+          <a:effectRef idx="2">
+            <a:schemeClr val="accent1"/>
+          </a:effectRef>
+          <a:fontRef idx="minor">
+            <a:schemeClr val="lt1"/>
+          </a:fontRef>
+        </p:style>
+        <p:txBody>
+          <a:bodyPr rtlCol="0" anchor="ctr" wrap="square" lIns="228600" rIns="228600"/>
+          <a:lstStyle/>
+          <a:p>
+            <a:pPr algn="ctr"/>
+            <a:r>
+              <a:rPr sz="1200" b="1" i="0">
+                <a:solidFill>
+                  <a:srgbClr val="E8590C"/>
+                </a:solidFill>
+                <a:latin typeface="Calibri"/>
+              </a:rPr>
+              <a:t>COMO FUNCIONA UM RAG</a:t>
+            </a:r>
+          </a:p>
+        </p:txBody>
+      </p:sp>
+      <p:sp>
+        <p:nvSpPr>
+          <p:cNvPr id="6" name="TextBox 6"/>
+          <p:cNvSpPr txBox="1"/>
+          <p:nvPr/>
+        </p:nvSpPr>
+        <p:spPr>
+          <a:xfrm>
+            <a:off x="914400" y="2331720"/>
+            <a:ext cx="4663440" cy="365760"/>
+          </a:xfrm>
+          <a:prstGeom prst="rect">
+            <a:avLst/>
+          </a:prstGeom>
+          <a:noFill/>
+        </p:spPr>
+        <p:txBody>
+          <a:bodyPr wrap="square" lIns="0" rIns="0" tIns="0" bIns="0">
+            <a:spAutoFit/>
+          </a:bodyPr>
+          <a:lstStyle/>
+          <a:p>
+            <a:pPr algn="l"/>
+            <a:r>
+              <a:rPr sz="1450" b="1" i="0">
+                <a:solidFill>
+                  <a:srgbClr val="1B2A4A"/>
+                </a:solidFill>
+                <a:latin typeface="Calibri"/>
+              </a:rPr>
+              <a:t>Busca por embedding decide o que o LLM lê</a:t>
+            </a:r>
+          </a:p>
+        </p:txBody>
+      </p:sp>
+      <p:sp>
+        <p:nvSpPr>
+          <p:cNvPr id="7" name="TextBox 7"/>
+          <p:cNvSpPr txBox="1"/>
+          <p:nvPr/>
+        </p:nvSpPr>
+        <p:spPr>
+          <a:xfrm>
+            <a:off x="914400" y="2770632"/>
+            <a:ext cx="4663440" cy="777240"/>
+          </a:xfrm>
+          <a:prstGeom prst="rect">
+            <a:avLst/>
+          </a:prstGeom>
+          <a:noFill/>
+        </p:spPr>
+        <p:txBody>
+          <a:bodyPr wrap="square" lIns="0" rIns="0" tIns="0" bIns="0">
+            <a:spAutoFit/>
+          </a:bodyPr>
+          <a:lstStyle/>
+          <a:p>
+            <a:pPr algn="l">
+              <a:lnSpc>
+                <a:spcPct val="110000"/>
+              </a:lnSpc>
+            </a:pPr>
+            <a:r>
+              <a:rPr sz="1200" b="0" i="1">
+                <a:solidFill>
+                  <a:srgbClr val="495057"/>
+                </a:solidFill>
+                <a:latin typeface="Calibri"/>
+              </a:rPr>
+              <a:t>Ferramentas que respondem sobre documentos longos (PDFs, livros) geralmente não mandam o texto inteiro ao modelo — quebram em pedaços (chunks) e recuperam só os mais similares à pergunta, por embedding</a:t>
+            </a:r>
+          </a:p>
+        </p:txBody>
+      </p:sp>
+      <p:sp>
+        <p:nvSpPr>
+          <p:cNvPr id="8" name="TextBox 8"/>
+          <p:cNvSpPr txBox="1"/>
+          <p:nvPr/>
+        </p:nvSpPr>
+        <p:spPr>
+          <a:xfrm>
+            <a:off x="914400" y="3593592"/>
+            <a:ext cx="4663440" cy="548640"/>
+          </a:xfrm>
+          <a:prstGeom prst="rect">
+            <a:avLst/>
+          </a:prstGeom>
+          <a:noFill/>
+        </p:spPr>
+        <p:txBody>
+          <a:bodyPr wrap="square" lIns="0" rIns="0" tIns="0" bIns="0">
+            <a:spAutoFit/>
+          </a:bodyPr>
+          <a:lstStyle/>
+          <a:p>
+            <a:pPr algn="l">
+              <a:lnSpc>
+                <a:spcPct val="110000"/>
+              </a:lnSpc>
+            </a:pPr>
+            <a:r>
+              <a:rPr sz="1200" b="0" i="0">
+                <a:solidFill>
+                  <a:srgbClr val="495057"/>
+                </a:solidFill>
+                <a:latin typeface="Calibri"/>
+              </a:rPr>
+              <a:t>→ um corte malfeito decide, antes do LLM entrar em ação, que ele nunca vai ver o trecho certo</a:t>
+            </a:r>
+          </a:p>
+        </p:txBody>
+      </p:sp>
+      <p:sp>
+        <p:nvSpPr>
+          <p:cNvPr id="11" name="TextBox 11"/>
+          <p:cNvSpPr txBox="1"/>
+          <p:nvPr/>
+        </p:nvSpPr>
+        <p:spPr>
+          <a:xfrm>
+            <a:off x="914400" y="4297680"/>
+            <a:ext cx="4663440" cy="365760"/>
+          </a:xfrm>
+          <a:prstGeom prst="rect">
+            <a:avLst/>
+          </a:prstGeom>
+          <a:noFill/>
+        </p:spPr>
+        <p:txBody>
+          <a:bodyPr wrap="square" lIns="0" rIns="0" tIns="0" bIns="0">
+            <a:spAutoFit/>
+          </a:bodyPr>
+          <a:lstStyle/>
+          <a:p>
+            <a:pPr algn="l"/>
+            <a:r>
+              <a:rPr sz="1250" b="1" i="0">
+                <a:solidFill>
+                  <a:srgbClr val="E8590C"/>
+                </a:solidFill>
+                <a:latin typeface="Calibri"/>
+              </a:rPr>
+              <a:t>a etapa de busca já erra antes do LLM começar</a:t>
+            </a:r>
+          </a:p>
+        </p:txBody>
+      </p:sp>
+      <p:sp>
+        <p:nvSpPr>
+          <p:cNvPr id="12" name="Rounded Rectangle 12"/>
+          <p:cNvSpPr/>
+          <p:nvPr/>
+        </p:nvSpPr>
+        <p:spPr>
+          <a:xfrm>
+            <a:off x="6309360" y="1600200"/>
+            <a:ext cx="5212080" cy="3246120"/>
+          </a:xfrm>
+          <a:prstGeom prst="roundRect">
+            <a:avLst>
+              <a:gd name="adj" fmla="val 6000"/>
+            </a:avLst>
+          </a:prstGeom>
+          <a:solidFill>
+            <a:srgbClr val="F6F7F9"/>
+          </a:solidFill>
+          <a:ln>
+            <a:noFill/>
+          </a:ln>
+          <a:effectLst/>
+        </p:spPr>
+        <p:style>
+          <a:lnRef idx="1">
+            <a:schemeClr val="accent1"/>
+          </a:lnRef>
+          <a:fillRef idx="3">
+            <a:schemeClr val="accent1"/>
+          </a:fillRef>
+          <a:effectRef idx="2">
+            <a:schemeClr val="accent1"/>
+          </a:effectRef>
+          <a:fontRef idx="minor">
+            <a:schemeClr val="lt1"/>
+          </a:fontRef>
+        </p:style>
+        <p:txBody>
+          <a:bodyPr rtlCol="0" anchor="ctr"/>
+          <a:lstStyle/>
+          <a:p>
+            <a:pPr algn="ctr"/>
+          </a:p>
+        </p:txBody>
+      </p:sp>
+      <p:sp>
+        <p:nvSpPr>
+          <p:cNvPr id="13" name="Rounded Rectangle 13"/>
+          <p:cNvSpPr/>
+          <p:nvPr/>
+        </p:nvSpPr>
+        <p:spPr>
+          <a:xfrm>
+            <a:off x="6583680" y="1856232"/>
+            <a:ext cx="2822000" cy="365760"/>
+          </a:xfrm>
+          <a:prstGeom prst="roundRect">
+            <a:avLst>
+              <a:gd name="adj" fmla="val 50000"/>
+            </a:avLst>
+          </a:prstGeom>
+          <a:solidFill>
+            <a:srgbClr val="FDECE0"/>
+          </a:solidFill>
+          <a:ln>
+            <a:noFill/>
+          </a:ln>
+          <a:effectLst/>
+        </p:spPr>
+        <p:style>
+          <a:lnRef idx="1">
+            <a:schemeClr val="accent1"/>
+          </a:lnRef>
+          <a:fillRef idx="3">
+            <a:schemeClr val="accent1"/>
+          </a:fillRef>
+          <a:effectRef idx="2">
+            <a:schemeClr val="accent1"/>
+          </a:effectRef>
+          <a:fontRef idx="minor">
+            <a:schemeClr val="lt1"/>
+          </a:fontRef>
+        </p:style>
+        <p:txBody>
+          <a:bodyPr rtlCol="0" anchor="ctr" wrap="square" lIns="228600" rIns="228600"/>
+          <a:lstStyle/>
+          <a:p>
+            <a:pPr algn="ctr"/>
+            <a:r>
+              <a:rPr sz="1200" b="1" i="0">
+                <a:solidFill>
+                  <a:srgbClr val="E8590C"/>
+                </a:solidFill>
+                <a:latin typeface="Calibri"/>
+              </a:rPr>
+              <a:t>ACHADO DESTE PROJETO</a:t>
+            </a:r>
+          </a:p>
+        </p:txBody>
+      </p:sp>
+      <p:sp>
+        <p:nvSpPr>
+          <p:cNvPr id="14" name="TextBox 14"/>
+          <p:cNvSpPr txBox="1"/>
+          <p:nvPr/>
+        </p:nvSpPr>
+        <p:spPr>
+          <a:xfrm>
+            <a:off x="6583680" y="2331720"/>
+            <a:ext cx="4663440" cy="365760"/>
+          </a:xfrm>
+          <a:prstGeom prst="rect">
+            <a:avLst/>
+          </a:prstGeom>
+          <a:noFill/>
+        </p:spPr>
+        <p:txBody>
+          <a:bodyPr wrap="square" lIns="0" rIns="0" tIns="0" bIns="0">
+            <a:spAutoFit/>
+          </a:bodyPr>
+          <a:lstStyle/>
+          <a:p>
+            <a:pPr algn="l"/>
+            <a:r>
+              <a:rPr sz="1450" b="1" i="0">
+                <a:solidFill>
+                  <a:srgbClr val="1B2A4A"/>
+                </a:solidFill>
+                <a:latin typeface="Calibri"/>
+              </a:rPr>
+              <a:t>Trecho cortado sem contexto = embedding degradado</a:t>
+            </a:r>
+          </a:p>
+        </p:txBody>
+      </p:sp>
+      <p:sp>
+        <p:nvSpPr>
+          <p:cNvPr id="15" name="TextBox 15"/>
+          <p:cNvSpPr txBox="1"/>
+          <p:nvPr/>
+        </p:nvSpPr>
+        <p:spPr>
+          <a:xfrm>
+            <a:off x="6583680" y="2770632"/>
+            <a:ext cx="4663440" cy="777240"/>
+          </a:xfrm>
+          <a:prstGeom prst="rect">
+            <a:avLst/>
+          </a:prstGeom>
+          <a:noFill/>
+        </p:spPr>
+        <p:txBody>
+          <a:bodyPr wrap="square" lIns="0" rIns="0" tIns="0" bIns="0">
+            <a:spAutoFit/>
+          </a:bodyPr>
+          <a:lstStyle/>
+          <a:p>
+            <a:pPr algn="l">
+              <a:lnSpc>
+                <a:spcPct val="110000"/>
+              </a:lnSpc>
+            </a:pPr>
+            <a:r>
+              <a:rPr sz="1200" b="0" i="1">
+                <a:solidFill>
+                  <a:srgbClr val="495057"/>
+                </a:solidFill>
+                <a:latin typeface="Calibri"/>
+              </a:rPr>
+              <a:t>Um conectivo pressuposicional (“mas ainda...”), uma referência não resolvida, uma citação sem o entorno — não é a complexidade do texto que derruba a similaridade, é o corte</a:t>
+            </a:r>
+          </a:p>
+        </p:txBody>
+      </p:sp>
+      <p:sp>
+        <p:nvSpPr>
+          <p:cNvPr id="16" name="TextBox 16"/>
+          <p:cNvSpPr txBox="1"/>
+          <p:nvPr/>
+        </p:nvSpPr>
+        <p:spPr>
+          <a:xfrm>
+            <a:off x="6583680" y="3593592"/>
+            <a:ext cx="4663440" cy="548640"/>
+          </a:xfrm>
+          <a:prstGeom prst="rect">
+            <a:avLst/>
+          </a:prstGeom>
+          <a:noFill/>
+        </p:spPr>
+        <p:txBody>
+          <a:bodyPr wrap="square" lIns="0" rIns="0" tIns="0" bIns="0">
+            <a:spAutoFit/>
+          </a:bodyPr>
+          <a:lstStyle/>
+          <a:p>
+            <a:pPr algn="l">
+              <a:lnSpc>
+                <a:spcPct val="110000"/>
+              </a:lnSpc>
+            </a:pPr>
+            <a:r>
+              <a:rPr sz="1200" b="0" i="0">
+                <a:solidFill>
+                  <a:srgbClr val="495057"/>
+                </a:solidFill>
+                <a:latin typeface="Calibri"/>
+              </a:rPr>
+              <a:t>→ o mesmo mecanismo medido aqui em literatura pode atuar em qualquer fronteira de chunk</a:t>
+            </a:r>
+          </a:p>
+        </p:txBody>
+      </p:sp>
+      <p:sp>
+        <p:nvSpPr>
+          <p:cNvPr id="19" name="TextBox 19"/>
+          <p:cNvSpPr txBox="1"/>
+          <p:nvPr/>
+        </p:nvSpPr>
+        <p:spPr>
+          <a:xfrm>
+            <a:off x="6583680" y="4297680"/>
+            <a:ext cx="4663440" cy="365760"/>
+          </a:xfrm>
+          <a:prstGeom prst="rect">
+            <a:avLst/>
+          </a:prstGeom>
+          <a:noFill/>
+        </p:spPr>
+        <p:txBody>
+          <a:bodyPr wrap="square" lIns="0" rIns="0" tIns="0" bIns="0">
+            <a:spAutoFit/>
+          </a:bodyPr>
+          <a:lstStyle/>
+          <a:p>
+            <a:pPr algn="l"/>
+            <a:r>
+              <a:rPr sz="1250" b="1" i="0">
+                <a:solidFill>
+                  <a:srgbClr val="E8590C"/>
+                </a:solidFill>
+                <a:latin typeface="Calibri"/>
+              </a:rPr>
+              <a:t>não é uma falha do LLM — é uma falha do recorte</a:t>
+            </a:r>
+          </a:p>
+        </p:txBody>
+      </p:sp>
+      <p:sp>
+        <p:nvSpPr>
+          <p:cNvPr id="20" name="Rounded Rectangle 20"/>
+          <p:cNvSpPr/>
+          <p:nvPr/>
+        </p:nvSpPr>
+        <p:spPr>
+          <a:xfrm>
+            <a:off x="640080" y="5532120"/>
+            <a:ext cx="10911535" cy="777240"/>
+          </a:xfrm>
+          <a:prstGeom prst="roundRect">
+            <a:avLst>
+              <a:gd name="adj" fmla="val 10000"/>
+            </a:avLst>
+          </a:prstGeom>
+          <a:solidFill>
+            <a:srgbClr val="E7ECFC"/>
+          </a:solidFill>
+          <a:ln>
+            <a:noFill/>
+          </a:ln>
+          <a:effectLst/>
+        </p:spPr>
+        <p:style>
+          <a:lnRef idx="1">
+            <a:schemeClr val="accent1"/>
+          </a:lnRef>
+          <a:fillRef idx="3">
+            <a:schemeClr val="accent1"/>
+          </a:fillRef>
+          <a:effectRef idx="2">
+            <a:schemeClr val="accent1"/>
+          </a:effectRef>
+          <a:fontRef idx="minor">
+            <a:schemeClr val="lt1"/>
+          </a:fontRef>
+        </p:style>
+        <p:txBody>
+          <a:bodyPr rtlCol="0" anchor="ctr" wrap="square" lIns="320040" rIns="320040"/>
+          <a:lstStyle/>
+          <a:p>
+            <a:pPr algn="l">
+              <a:lnSpc>
+                <a:spcPct val="115000"/>
+              </a:lnSpc>
+            </a:pPr>
+            <a:r>
+              <a:rPr sz="1300" b="0" i="1">
+                <a:solidFill>
+                  <a:srgbClr val="1B2A4A"/>
+                </a:solidFill>
+                <a:latin typeface="Calibri"/>
+              </a:rPr>
+              <a:t>Isso ainda não foi testado em texto não-literário nem contra diferentes estratégias de corte de chunk — é uma pergunta de continuidade registrada no projeto, não uma conclusão fechada. Mas é testável: comparar a resposta da IA sobre um trecho colado com e sem o contexto ao redor.</a:t>
+            </a:r>
+          </a:p>
+        </p:txBody>
+      </p:sp>
+      <p:sp>
+        <p:nvSpPr>
+          <p:cNvPr id="21" name="TextBox 21"/>
+          <p:cNvSpPr txBox="1"/>
+          <p:nvPr/>
+        </p:nvSpPr>
+        <p:spPr>
+          <a:xfrm>
+            <a:off x="640080" y="6400800"/>
+            <a:ext cx="5486400" cy="320040"/>
+          </a:xfrm>
+          <a:prstGeom prst="rect">
+            <a:avLst/>
+          </a:prstGeom>
+          <a:noFill/>
+        </p:spPr>
+        <p:txBody>
+          <a:bodyPr wrap="square" lIns="0" rIns="0" tIns="0" bIns="0">
+            <a:spAutoFit/>
+          </a:bodyPr>
+          <a:lstStyle/>
+          <a:p>
+            <a:pPr algn="l"/>
+            <a:r>
+              <a:rPr sz="1000" b="0" i="0">
+                <a:solidFill>
+                  <a:srgbClr val="868E96"/>
+                </a:solidFill>
+                <a:latin typeface="Calibri"/>
+              </a:rPr>
+              <a:t>Laboratório de Estresse Semântico</a:t>
+            </a:r>
+          </a:p>
+        </p:txBody>
+      </p:sp>
+      <p:sp>
+        <p:nvSpPr>
+          <p:cNvPr id="22" name="TextBox 22"/>
+          <p:cNvSpPr txBox="1"/>
+          <p:nvPr/>
+        </p:nvSpPr>
+        <p:spPr>
+          <a:xfrm>
+            <a:off x="10637215" y="6400800"/>
+            <a:ext cx="914400" cy="320040"/>
+          </a:xfrm>
+          <a:prstGeom prst="rect">
+            <a:avLst/>
+          </a:prstGeom>
+          <a:noFill/>
+        </p:spPr>
+        <p:txBody>
+          <a:bodyPr wrap="square" lIns="0" rIns="0" tIns="0" bIns="0">
+            <a:spAutoFit/>
+          </a:bodyPr>
+          <a:lstStyle/>
+          <a:p>
+            <a:pPr algn="r"/>
+            <a:r>
+              <a:rPr sz="1000" b="0" i="0">
+                <a:solidFill>
+                  <a:srgbClr val="868E96"/>
+                </a:solidFill>
+                <a:latin typeface="Calibri"/>
+              </a:rPr>
+              <a:t>13</a:t>
+            </a:r>
+          </a:p>
+        </p:txBody>
+      </p:sp>
+    </p:spTree>
+  </p:cSld>
+  <p:clrMapOvr>
+    <a:masterClrMapping/>
+  </p:clrMapOvr>
+</p:sld>
+</file>
+
 <file path=ppt/slides/slide2.xml><?xml version="1.0" encoding="utf-8"?>
 <p:sld xmlns:a="http://schemas.openxmlformats.org/drawingml/2006/main" xmlns:p="http://schemas.openxmlformats.org/presentationml/2006/main" xmlns:r="http://schemas.openxmlformats.org/officeDocument/2006/relationships">
   <p:cSld>
@@ -10728,7 +11452,7 @@
                 </a:solidFill>
                 <a:latin typeface="Calibri"/>
               </a:rPr>
-              <a:t>13</a:t>
+              <a:t>14</a:t>
             </a:r>
           </a:p>
         </p:txBody>

</xml_diff>